<commit_message>
Presentation Charting | UI clearn-up | diagram
</commit_message>
<xml_diff>
--- a/data/templates/mbr_template.pptx
+++ b/data/templates/mbr_template.pptx
@@ -119,49 +119,2965 @@
 </p:presentation>
 </file>
 
+<file path=ppt/revisionInfo.xml><?xml version="1.0" encoding="utf-8"?>
+<p1510:revInfo xmlns:a="http://schemas.openxmlformats.org/drawingml/2006/main" xmlns:r="http://schemas.openxmlformats.org/officeDocument/2006/relationships" xmlns:p1510="http://schemas.microsoft.com/office/powerpoint/2015/10/main">
+  <p1510:revLst>
+    <p1510:client id="{F5EA2391-A0E5-47E1-AE35-57520531FEB0}" v="15" dt="2026-06-22T15:15:18.205"/>
+  </p1510:revLst>
+</p1510:revInfo>
+</file>
+
 <file path=ppt/changesInfos/changesInfo1.xml><?xml version="1.0" encoding="utf-8"?>
 <pc:chgInfo xmlns:a="http://schemas.openxmlformats.org/drawingml/2006/main" xmlns:r="http://schemas.openxmlformats.org/officeDocument/2006/relationships" xmlns:ac="http://schemas.microsoft.com/office/drawing/2013/main/command" xmlns:pc="http://schemas.microsoft.com/office/powerpoint/2013/main/command">
   <pc:docChgLst>
     <pc:chgData name="Jonathan Scholtes" userId="e880d0af-1f43-427b-913b-f3abafcb9228" providerId="ADAL" clId="{953A541B-BE96-470D-8FB3-572B734343FF}"/>
     <pc:docChg chg="modSld">
-      <pc:chgData name="Jonathan Scholtes" userId="e880d0af-1f43-427b-913b-f3abafcb9228" providerId="ADAL" clId="{953A541B-BE96-470D-8FB3-572B734343FF}" dt="2026-06-18T04:20:32.740" v="11"/>
+      <pc:chgData name="Jonathan Scholtes" userId="e880d0af-1f43-427b-913b-f3abafcb9228" providerId="ADAL" clId="{953A541B-BE96-470D-8FB3-572B734343FF}" dt="2026-06-22T15:17:25.926" v="2" actId="255"/>
       <pc:docMkLst>
         <pc:docMk/>
       </pc:docMkLst>
       <pc:sldChg chg="modSp mod">
-        <pc:chgData name="Jonathan Scholtes" userId="e880d0af-1f43-427b-913b-f3abafcb9228" providerId="ADAL" clId="{953A541B-BE96-470D-8FB3-572B734343FF}" dt="2026-06-18T04:20:32.740" v="11"/>
+        <pc:chgData name="Jonathan Scholtes" userId="e880d0af-1f43-427b-913b-f3abafcb9228" providerId="ADAL" clId="{953A541B-BE96-470D-8FB3-572B734343FF}" dt="2026-06-22T15:17:25.926" v="2" actId="255"/>
         <pc:sldMkLst>
           <pc:docMk/>
-          <pc:sldMk cId="0" sldId="257"/>
+          <pc:sldMk cId="0" sldId="262"/>
         </pc:sldMkLst>
         <pc:spChg chg="mod">
-          <ac:chgData name="Jonathan Scholtes" userId="e880d0af-1f43-427b-913b-f3abafcb9228" providerId="ADAL" clId="{953A541B-BE96-470D-8FB3-572B734343FF}" dt="2026-06-18T04:20:05.640" v="9" actId="20577"/>
+          <ac:chgData name="Jonathan Scholtes" userId="e880d0af-1f43-427b-913b-f3abafcb9228" providerId="ADAL" clId="{953A541B-BE96-470D-8FB3-572B734343FF}" dt="2026-06-22T15:17:21.029" v="1" actId="255"/>
           <ac:spMkLst>
             <pc:docMk/>
-            <pc:sldMk cId="0" sldId="257"/>
-            <ac:spMk id="14" creationId="{00000000-0000-0000-0000-000000000000}"/>
+            <pc:sldMk cId="0" sldId="262"/>
+            <ac:spMk id="7" creationId="{00000000-0000-0000-0000-000000000000}"/>
           </ac:spMkLst>
         </pc:spChg>
         <pc:spChg chg="mod">
-          <ac:chgData name="Jonathan Scholtes" userId="e880d0af-1f43-427b-913b-f3abafcb9228" providerId="ADAL" clId="{953A541B-BE96-470D-8FB3-572B734343FF}" dt="2026-06-18T04:20:20.514" v="10"/>
+          <ac:chgData name="Jonathan Scholtes" userId="e880d0af-1f43-427b-913b-f3abafcb9228" providerId="ADAL" clId="{953A541B-BE96-470D-8FB3-572B734343FF}" dt="2026-06-22T15:17:17.464" v="0" actId="255"/>
           <ac:spMkLst>
             <pc:docMk/>
-            <pc:sldMk cId="0" sldId="257"/>
-            <ac:spMk id="19" creationId="{00000000-0000-0000-0000-000000000000}"/>
+            <pc:sldMk cId="0" sldId="262"/>
+            <ac:spMk id="11" creationId="{00000000-0000-0000-0000-000000000000}"/>
           </ac:spMkLst>
         </pc:spChg>
         <pc:spChg chg="mod">
-          <ac:chgData name="Jonathan Scholtes" userId="e880d0af-1f43-427b-913b-f3abafcb9228" providerId="ADAL" clId="{953A541B-BE96-470D-8FB3-572B734343FF}" dt="2026-06-18T04:20:32.740" v="11"/>
+          <ac:chgData name="Jonathan Scholtes" userId="e880d0af-1f43-427b-913b-f3abafcb9228" providerId="ADAL" clId="{953A541B-BE96-470D-8FB3-572B734343FF}" dt="2026-06-22T15:17:25.926" v="2" actId="255"/>
           <ac:spMkLst>
             <pc:docMk/>
-            <pc:sldMk cId="0" sldId="257"/>
-            <ac:spMk id="29" creationId="{00000000-0000-0000-0000-000000000000}"/>
+            <pc:sldMk cId="0" sldId="262"/>
+            <ac:spMk id="12" creationId="{00000000-0000-0000-0000-000000000000}"/>
           </ac:spMkLst>
         </pc:spChg>
       </pc:sldChg>
     </pc:docChg>
   </pc:docChgLst>
 </pc:chgInfo>
+</file>
+
+<file path=ppt/charts/chart1.xml><?xml version="1.0" encoding="utf-8"?>
+<c:chartSpace xmlns:c="http://schemas.openxmlformats.org/drawingml/2006/chart" xmlns:a="http://schemas.openxmlformats.org/drawingml/2006/main" xmlns:r="http://schemas.openxmlformats.org/officeDocument/2006/relationships" xmlns:c16r2="http://schemas.microsoft.com/office/drawing/2015/06/chart">
+  <c:date1904 val="0"/>
+  <c:lang val="en-US"/>
+  <c:roundedCorners val="0"/>
+  <mc:AlternateContent xmlns:mc="http://schemas.openxmlformats.org/markup-compatibility/2006">
+    <mc:Choice xmlns:c14="http://schemas.microsoft.com/office/drawing/2007/8/2/chart" Requires="c14">
+      <c14:style val="102"/>
+    </mc:Choice>
+    <mc:Fallback>
+      <c:style val="2"/>
+    </mc:Fallback>
+  </mc:AlternateContent>
+  <c:chart>
+    <c:title>
+      <c:tx>
+        <c:rich>
+          <a:bodyPr rot="0" spcFirstLastPara="1" vertOverflow="ellipsis" vert="horz" wrap="square" anchor="ctr" anchorCtr="1"/>
+          <a:lstStyle/>
+          <a:p>
+            <a:pPr>
+              <a:defRPr sz="1862" b="0" i="0" u="none" strike="noStrike" kern="1200" spc="0" baseline="0">
+                <a:solidFill>
+                  <a:schemeClr val="tx1">
+                    <a:lumMod val="65000"/>
+                    <a:lumOff val="35000"/>
+                  </a:schemeClr>
+                </a:solidFill>
+                <a:latin typeface="+mn-lt"/>
+                <a:ea typeface="+mn-ea"/>
+                <a:cs typeface="+mn-cs"/>
+              </a:defRPr>
+            </a:pPr>
+            <a:r>
+              <a:rPr lang="en-US" sz="1800" b="0" dirty="0">
+                <a:effectLst/>
+              </a:rPr>
+              <a:t>Revenue Trend</a:t>
+            </a:r>
+          </a:p>
+        </c:rich>
+      </c:tx>
+      <c:overlay val="0"/>
+      <c:spPr>
+        <a:noFill/>
+        <a:ln>
+          <a:noFill/>
+        </a:ln>
+        <a:effectLst/>
+      </c:spPr>
+      <c:txPr>
+        <a:bodyPr rot="0" spcFirstLastPara="1" vertOverflow="ellipsis" vert="horz" wrap="square" anchor="ctr" anchorCtr="1"/>
+        <a:lstStyle/>
+        <a:p>
+          <a:pPr>
+            <a:defRPr sz="1862" b="0" i="0" u="none" strike="noStrike" kern="1200" spc="0" baseline="0">
+              <a:solidFill>
+                <a:schemeClr val="tx1">
+                  <a:lumMod val="65000"/>
+                  <a:lumOff val="35000"/>
+                </a:schemeClr>
+              </a:solidFill>
+              <a:latin typeface="+mn-lt"/>
+              <a:ea typeface="+mn-ea"/>
+              <a:cs typeface="+mn-cs"/>
+            </a:defRPr>
+          </a:pPr>
+          <a:endParaRPr lang="en-US"/>
+        </a:p>
+      </c:txPr>
+    </c:title>
+    <c:autoTitleDeleted val="0"/>
+    <c:plotArea>
+      <c:layout/>
+      <c:lineChart>
+        <c:grouping val="standard"/>
+        <c:varyColors val="0"/>
+        <c:ser>
+          <c:idx val="0"/>
+          <c:order val="0"/>
+          <c:tx>
+            <c:strRef>
+              <c:f>Sheet1!$B$1</c:f>
+              <c:strCache>
+                <c:ptCount val="1"/>
+                <c:pt idx="0">
+                  <c:v>Revenue ($M)</c:v>
+                </c:pt>
+              </c:strCache>
+            </c:strRef>
+          </c:tx>
+          <c:spPr>
+            <a:ln w="28575" cap="rnd">
+              <a:solidFill>
+                <a:schemeClr val="accent1"/>
+              </a:solidFill>
+              <a:round/>
+            </a:ln>
+            <a:effectLst/>
+          </c:spPr>
+          <c:marker>
+            <c:symbol val="none"/>
+          </c:marker>
+          <c:cat>
+            <c:numRef>
+              <c:f>Sheet1!$A$2:$A$5</c:f>
+              <c:numCache>
+                <c:formatCode>mmm\-yy</c:formatCode>
+                <c:ptCount val="4"/>
+                <c:pt idx="0">
+                  <c:v>45566</c:v>
+                </c:pt>
+                <c:pt idx="1">
+                  <c:v>45597</c:v>
+                </c:pt>
+                <c:pt idx="2">
+                  <c:v>45627</c:v>
+                </c:pt>
+                <c:pt idx="3">
+                  <c:v>45658</c:v>
+                </c:pt>
+              </c:numCache>
+            </c:numRef>
+          </c:cat>
+          <c:val>
+            <c:numRef>
+              <c:f>Sheet1!$B$2:$B$5</c:f>
+              <c:numCache>
+                <c:formatCode>General</c:formatCode>
+                <c:ptCount val="4"/>
+                <c:pt idx="0">
+                  <c:v>1.37</c:v>
+                </c:pt>
+                <c:pt idx="1">
+                  <c:v>1.39</c:v>
+                </c:pt>
+                <c:pt idx="2">
+                  <c:v>1.4</c:v>
+                </c:pt>
+                <c:pt idx="3">
+                  <c:v>1.42</c:v>
+                </c:pt>
+              </c:numCache>
+            </c:numRef>
+          </c:val>
+          <c:smooth val="0"/>
+          <c:extLst>
+            <c:ext xmlns:c16="http://schemas.microsoft.com/office/drawing/2014/chart" uri="{C3380CC4-5D6E-409C-BE32-E72D297353CC}">
+              <c16:uniqueId val="{00000000-094B-4725-93C2-4048E33C25B7}"/>
+            </c:ext>
+          </c:extLst>
+        </c:ser>
+        <c:ser>
+          <c:idx val="1"/>
+          <c:order val="1"/>
+          <c:tx>
+            <c:strRef>
+              <c:f>Sheet1!$C$1</c:f>
+              <c:strCache>
+                <c:ptCount val="1"/>
+              </c:strCache>
+            </c:strRef>
+          </c:tx>
+          <c:spPr>
+            <a:ln w="28575" cap="rnd">
+              <a:solidFill>
+                <a:schemeClr val="accent2"/>
+              </a:solidFill>
+              <a:round/>
+            </a:ln>
+            <a:effectLst/>
+          </c:spPr>
+          <c:marker>
+            <c:symbol val="none"/>
+          </c:marker>
+          <c:cat>
+            <c:numRef>
+              <c:f>Sheet1!$A$2:$A$5</c:f>
+              <c:numCache>
+                <c:formatCode>mmm\-yy</c:formatCode>
+                <c:ptCount val="4"/>
+                <c:pt idx="0">
+                  <c:v>45566</c:v>
+                </c:pt>
+                <c:pt idx="1">
+                  <c:v>45597</c:v>
+                </c:pt>
+                <c:pt idx="2">
+                  <c:v>45627</c:v>
+                </c:pt>
+                <c:pt idx="3">
+                  <c:v>45658</c:v>
+                </c:pt>
+              </c:numCache>
+            </c:numRef>
+          </c:cat>
+          <c:val>
+            <c:numRef>
+              <c:f>Sheet1!$C$2:$C$5</c:f>
+              <c:numCache>
+                <c:formatCode>General</c:formatCode>
+                <c:ptCount val="4"/>
+              </c:numCache>
+            </c:numRef>
+          </c:val>
+          <c:smooth val="0"/>
+          <c:extLst>
+            <c:ext xmlns:c16="http://schemas.microsoft.com/office/drawing/2014/chart" uri="{C3380CC4-5D6E-409C-BE32-E72D297353CC}">
+              <c16:uniqueId val="{00000001-094B-4725-93C2-4048E33C25B7}"/>
+            </c:ext>
+          </c:extLst>
+        </c:ser>
+        <c:ser>
+          <c:idx val="2"/>
+          <c:order val="2"/>
+          <c:tx>
+            <c:strRef>
+              <c:f>Sheet1!$D$1</c:f>
+              <c:strCache>
+                <c:ptCount val="1"/>
+              </c:strCache>
+            </c:strRef>
+          </c:tx>
+          <c:spPr>
+            <a:ln w="28575" cap="rnd">
+              <a:solidFill>
+                <a:schemeClr val="accent3"/>
+              </a:solidFill>
+              <a:round/>
+            </a:ln>
+            <a:effectLst/>
+          </c:spPr>
+          <c:marker>
+            <c:symbol val="none"/>
+          </c:marker>
+          <c:cat>
+            <c:numRef>
+              <c:f>Sheet1!$A$2:$A$5</c:f>
+              <c:numCache>
+                <c:formatCode>mmm\-yy</c:formatCode>
+                <c:ptCount val="4"/>
+                <c:pt idx="0">
+                  <c:v>45566</c:v>
+                </c:pt>
+                <c:pt idx="1">
+                  <c:v>45597</c:v>
+                </c:pt>
+                <c:pt idx="2">
+                  <c:v>45627</c:v>
+                </c:pt>
+                <c:pt idx="3">
+                  <c:v>45658</c:v>
+                </c:pt>
+              </c:numCache>
+            </c:numRef>
+          </c:cat>
+          <c:val>
+            <c:numRef>
+              <c:f>Sheet1!$D$2:$D$5</c:f>
+              <c:numCache>
+                <c:formatCode>General</c:formatCode>
+                <c:ptCount val="4"/>
+              </c:numCache>
+            </c:numRef>
+          </c:val>
+          <c:smooth val="0"/>
+          <c:extLst>
+            <c:ext xmlns:c16="http://schemas.microsoft.com/office/drawing/2014/chart" uri="{C3380CC4-5D6E-409C-BE32-E72D297353CC}">
+              <c16:uniqueId val="{00000002-094B-4725-93C2-4048E33C25B7}"/>
+            </c:ext>
+          </c:extLst>
+        </c:ser>
+        <c:dLbls>
+          <c:showLegendKey val="0"/>
+          <c:showVal val="0"/>
+          <c:showCatName val="0"/>
+          <c:showSerName val="0"/>
+          <c:showPercent val="0"/>
+          <c:showBubbleSize val="0"/>
+        </c:dLbls>
+        <c:smooth val="0"/>
+        <c:axId val="1137624431"/>
+        <c:axId val="1129240783"/>
+      </c:lineChart>
+      <c:dateAx>
+        <c:axId val="1137624431"/>
+        <c:scaling>
+          <c:orientation val="minMax"/>
+        </c:scaling>
+        <c:delete val="0"/>
+        <c:axPos val="b"/>
+        <c:numFmt formatCode="mmm\-yy" sourceLinked="1"/>
+        <c:majorTickMark val="none"/>
+        <c:minorTickMark val="none"/>
+        <c:tickLblPos val="nextTo"/>
+        <c:spPr>
+          <a:noFill/>
+          <a:ln w="9525" cap="flat" cmpd="sng" algn="ctr">
+            <a:solidFill>
+              <a:schemeClr val="tx1">
+                <a:lumMod val="15000"/>
+                <a:lumOff val="85000"/>
+              </a:schemeClr>
+            </a:solidFill>
+            <a:round/>
+          </a:ln>
+          <a:effectLst/>
+        </c:spPr>
+        <c:txPr>
+          <a:bodyPr rot="-60000000" spcFirstLastPara="1" vertOverflow="ellipsis" vert="horz" wrap="square" anchor="ctr" anchorCtr="1"/>
+          <a:lstStyle/>
+          <a:p>
+            <a:pPr>
+              <a:defRPr sz="1197" b="0" i="0" u="none" strike="noStrike" kern="1200" baseline="0">
+                <a:solidFill>
+                  <a:schemeClr val="tx1">
+                    <a:lumMod val="65000"/>
+                    <a:lumOff val="35000"/>
+                  </a:schemeClr>
+                </a:solidFill>
+                <a:latin typeface="+mn-lt"/>
+                <a:ea typeface="+mn-ea"/>
+                <a:cs typeface="+mn-cs"/>
+              </a:defRPr>
+            </a:pPr>
+            <a:endParaRPr lang="en-US"/>
+          </a:p>
+        </c:txPr>
+        <c:crossAx val="1129240783"/>
+        <c:crosses val="autoZero"/>
+        <c:auto val="1"/>
+        <c:lblOffset val="100"/>
+        <c:baseTimeUnit val="months"/>
+      </c:dateAx>
+      <c:valAx>
+        <c:axId val="1129240783"/>
+        <c:scaling>
+          <c:orientation val="minMax"/>
+        </c:scaling>
+        <c:delete val="0"/>
+        <c:axPos val="l"/>
+        <c:majorGridlines>
+          <c:spPr>
+            <a:ln w="9525" cap="flat" cmpd="sng" algn="ctr">
+              <a:solidFill>
+                <a:schemeClr val="tx1">
+                  <a:lumMod val="15000"/>
+                  <a:lumOff val="85000"/>
+                </a:schemeClr>
+              </a:solidFill>
+              <a:round/>
+            </a:ln>
+            <a:effectLst/>
+          </c:spPr>
+        </c:majorGridlines>
+        <c:numFmt formatCode="General" sourceLinked="1"/>
+        <c:majorTickMark val="none"/>
+        <c:minorTickMark val="none"/>
+        <c:tickLblPos val="nextTo"/>
+        <c:spPr>
+          <a:noFill/>
+          <a:ln>
+            <a:noFill/>
+          </a:ln>
+          <a:effectLst/>
+        </c:spPr>
+        <c:txPr>
+          <a:bodyPr rot="-60000000" spcFirstLastPara="1" vertOverflow="ellipsis" vert="horz" wrap="square" anchor="ctr" anchorCtr="1"/>
+          <a:lstStyle/>
+          <a:p>
+            <a:pPr>
+              <a:defRPr sz="1197" b="0" i="0" u="none" strike="noStrike" kern="1200" baseline="0">
+                <a:solidFill>
+                  <a:schemeClr val="tx1">
+                    <a:lumMod val="65000"/>
+                    <a:lumOff val="35000"/>
+                  </a:schemeClr>
+                </a:solidFill>
+                <a:latin typeface="+mn-lt"/>
+                <a:ea typeface="+mn-ea"/>
+                <a:cs typeface="+mn-cs"/>
+              </a:defRPr>
+            </a:pPr>
+            <a:endParaRPr lang="en-US"/>
+          </a:p>
+        </c:txPr>
+        <c:crossAx val="1137624431"/>
+        <c:crosses val="autoZero"/>
+        <c:crossBetween val="between"/>
+      </c:valAx>
+      <c:spPr>
+        <a:noFill/>
+        <a:ln>
+          <a:noFill/>
+        </a:ln>
+        <a:effectLst/>
+      </c:spPr>
+    </c:plotArea>
+    <c:legend>
+      <c:legendPos val="b"/>
+      <c:overlay val="0"/>
+      <c:spPr>
+        <a:noFill/>
+        <a:ln>
+          <a:noFill/>
+        </a:ln>
+        <a:effectLst/>
+      </c:spPr>
+      <c:txPr>
+        <a:bodyPr rot="0" spcFirstLastPara="1" vertOverflow="ellipsis" vert="horz" wrap="square" anchor="ctr" anchorCtr="1"/>
+        <a:lstStyle/>
+        <a:p>
+          <a:pPr>
+            <a:defRPr sz="1197" b="0" i="0" u="none" strike="noStrike" kern="1200" baseline="0">
+              <a:solidFill>
+                <a:schemeClr val="tx1">
+                  <a:lumMod val="65000"/>
+                  <a:lumOff val="35000"/>
+                </a:schemeClr>
+              </a:solidFill>
+              <a:latin typeface="+mn-lt"/>
+              <a:ea typeface="+mn-ea"/>
+              <a:cs typeface="+mn-cs"/>
+            </a:defRPr>
+          </a:pPr>
+          <a:endParaRPr lang="en-US"/>
+        </a:p>
+      </c:txPr>
+    </c:legend>
+    <c:plotVisOnly val="1"/>
+    <c:dispBlanksAs val="gap"/>
+    <c:showDLblsOverMax val="0"/>
+    <c:extLst>
+      <c:ext xmlns:c16r3="http://schemas.microsoft.com/office/drawing/2017/03/chart" uri="{56B9EC1D-385E-4148-901F-78D8002777C0}">
+        <c16r3:dataDisplayOptions16>
+          <c16r3:dispNaAsBlank val="1"/>
+        </c16r3:dataDisplayOptions16>
+      </c:ext>
+    </c:extLst>
+  </c:chart>
+  <c:spPr>
+    <a:noFill/>
+    <a:ln>
+      <a:noFill/>
+    </a:ln>
+    <a:effectLst/>
+  </c:spPr>
+  <c:txPr>
+    <a:bodyPr/>
+    <a:lstStyle/>
+    <a:p>
+      <a:pPr>
+        <a:defRPr/>
+      </a:pPr>
+      <a:endParaRPr lang="en-US"/>
+    </a:p>
+  </c:txPr>
+  <c:externalData r:id="rId3">
+    <c:autoUpdate val="0"/>
+  </c:externalData>
+</c:chartSpace>
+</file>
+
+<file path=ppt/charts/chart2.xml><?xml version="1.0" encoding="utf-8"?>
+<c:chartSpace xmlns:c="http://schemas.openxmlformats.org/drawingml/2006/chart" xmlns:a="http://schemas.openxmlformats.org/drawingml/2006/main" xmlns:r="http://schemas.openxmlformats.org/officeDocument/2006/relationships" xmlns:c16r2="http://schemas.microsoft.com/office/drawing/2015/06/chart">
+  <c:date1904 val="0"/>
+  <c:lang val="en-US"/>
+  <c:roundedCorners val="0"/>
+  <mc:AlternateContent xmlns:mc="http://schemas.openxmlformats.org/markup-compatibility/2006">
+    <mc:Choice xmlns:c14="http://schemas.microsoft.com/office/drawing/2007/8/2/chart" Requires="c14">
+      <c14:style val="102"/>
+    </mc:Choice>
+    <mc:Fallback>
+      <c:style val="2"/>
+    </mc:Fallback>
+  </mc:AlternateContent>
+  <c:chart>
+    <c:title>
+      <c:tx>
+        <c:rich>
+          <a:bodyPr rot="0" spcFirstLastPara="1" vertOverflow="ellipsis" vert="horz" wrap="square" anchor="ctr" anchorCtr="1"/>
+          <a:lstStyle/>
+          <a:p>
+            <a:pPr>
+              <a:defRPr sz="1862" b="0" i="0" u="none" strike="noStrike" kern="1200" spc="0" baseline="0">
+                <a:solidFill>
+                  <a:schemeClr val="tx1">
+                    <a:lumMod val="65000"/>
+                    <a:lumOff val="35000"/>
+                  </a:schemeClr>
+                </a:solidFill>
+                <a:latin typeface="+mn-lt"/>
+                <a:ea typeface="+mn-ea"/>
+                <a:cs typeface="+mn-cs"/>
+              </a:defRPr>
+            </a:pPr>
+            <a:r>
+              <a:rPr lang="en-US" sz="1800" b="0" dirty="0">
+                <a:effectLst/>
+              </a:rPr>
+              <a:t>Cost Breakdown</a:t>
+            </a:r>
+          </a:p>
+        </c:rich>
+      </c:tx>
+      <c:overlay val="0"/>
+      <c:spPr>
+        <a:noFill/>
+        <a:ln>
+          <a:noFill/>
+        </a:ln>
+        <a:effectLst/>
+      </c:spPr>
+      <c:txPr>
+        <a:bodyPr rot="0" spcFirstLastPara="1" vertOverflow="ellipsis" vert="horz" wrap="square" anchor="ctr" anchorCtr="1"/>
+        <a:lstStyle/>
+        <a:p>
+          <a:pPr>
+            <a:defRPr sz="1862" b="0" i="0" u="none" strike="noStrike" kern="1200" spc="0" baseline="0">
+              <a:solidFill>
+                <a:schemeClr val="tx1">
+                  <a:lumMod val="65000"/>
+                  <a:lumOff val="35000"/>
+                </a:schemeClr>
+              </a:solidFill>
+              <a:latin typeface="+mn-lt"/>
+              <a:ea typeface="+mn-ea"/>
+              <a:cs typeface="+mn-cs"/>
+            </a:defRPr>
+          </a:pPr>
+          <a:endParaRPr lang="en-US"/>
+        </a:p>
+      </c:txPr>
+    </c:title>
+    <c:autoTitleDeleted val="0"/>
+    <c:plotArea>
+      <c:layout/>
+      <c:barChart>
+        <c:barDir val="col"/>
+        <c:grouping val="clustered"/>
+        <c:varyColors val="0"/>
+        <c:ser>
+          <c:idx val="0"/>
+          <c:order val="0"/>
+          <c:tx>
+            <c:strRef>
+              <c:f>Sheet1!$B$1</c:f>
+              <c:strCache>
+                <c:ptCount val="1"/>
+                <c:pt idx="0">
+                  <c:v>Amount</c:v>
+                </c:pt>
+              </c:strCache>
+            </c:strRef>
+          </c:tx>
+          <c:spPr>
+            <a:solidFill>
+              <a:schemeClr val="accent1"/>
+            </a:solidFill>
+            <a:ln>
+              <a:noFill/>
+            </a:ln>
+            <a:effectLst/>
+          </c:spPr>
+          <c:invertIfNegative val="0"/>
+          <c:cat>
+            <c:strRef>
+              <c:f>Sheet1!$A$2:$A$5</c:f>
+              <c:strCache>
+                <c:ptCount val="4"/>
+                <c:pt idx="0">
+                  <c:v>Fuel</c:v>
+                </c:pt>
+                <c:pt idx="1">
+                  <c:v>Labor</c:v>
+                </c:pt>
+                <c:pt idx="2">
+                  <c:v>Maintenance</c:v>
+                </c:pt>
+                <c:pt idx="3">
+                  <c:v>Other</c:v>
+                </c:pt>
+              </c:strCache>
+            </c:strRef>
+          </c:cat>
+          <c:val>
+            <c:numRef>
+              <c:f>Sheet1!$B$2:$B$5</c:f>
+              <c:numCache>
+                <c:formatCode>General</c:formatCode>
+                <c:ptCount val="4"/>
+                <c:pt idx="0">
+                  <c:v>404600</c:v>
+                </c:pt>
+                <c:pt idx="1">
+                  <c:v>505750</c:v>
+                </c:pt>
+                <c:pt idx="2">
+                  <c:v>86700</c:v>
+                </c:pt>
+                <c:pt idx="3">
+                  <c:v>115600</c:v>
+                </c:pt>
+              </c:numCache>
+            </c:numRef>
+          </c:val>
+          <c:extLst>
+            <c:ext xmlns:c16="http://schemas.microsoft.com/office/drawing/2014/chart" uri="{C3380CC4-5D6E-409C-BE32-E72D297353CC}">
+              <c16:uniqueId val="{00000000-4262-496B-8E51-EAD9C5FC3963}"/>
+            </c:ext>
+          </c:extLst>
+        </c:ser>
+        <c:ser>
+          <c:idx val="1"/>
+          <c:order val="1"/>
+          <c:tx>
+            <c:strRef>
+              <c:f>Sheet1!$C$1</c:f>
+              <c:strCache>
+                <c:ptCount val="1"/>
+              </c:strCache>
+            </c:strRef>
+          </c:tx>
+          <c:spPr>
+            <a:solidFill>
+              <a:schemeClr val="accent2"/>
+            </a:solidFill>
+            <a:ln>
+              <a:noFill/>
+            </a:ln>
+            <a:effectLst/>
+          </c:spPr>
+          <c:invertIfNegative val="0"/>
+          <c:cat>
+            <c:strRef>
+              <c:f>Sheet1!$A$2:$A$5</c:f>
+              <c:strCache>
+                <c:ptCount val="4"/>
+                <c:pt idx="0">
+                  <c:v>Fuel</c:v>
+                </c:pt>
+                <c:pt idx="1">
+                  <c:v>Labor</c:v>
+                </c:pt>
+                <c:pt idx="2">
+                  <c:v>Maintenance</c:v>
+                </c:pt>
+                <c:pt idx="3">
+                  <c:v>Other</c:v>
+                </c:pt>
+              </c:strCache>
+            </c:strRef>
+          </c:cat>
+          <c:val>
+            <c:numRef>
+              <c:f>Sheet1!$C$2:$C$5</c:f>
+              <c:numCache>
+                <c:formatCode>General</c:formatCode>
+                <c:ptCount val="4"/>
+              </c:numCache>
+            </c:numRef>
+          </c:val>
+          <c:extLst>
+            <c:ext xmlns:c16="http://schemas.microsoft.com/office/drawing/2014/chart" uri="{C3380CC4-5D6E-409C-BE32-E72D297353CC}">
+              <c16:uniqueId val="{00000001-4262-496B-8E51-EAD9C5FC3963}"/>
+            </c:ext>
+          </c:extLst>
+        </c:ser>
+        <c:ser>
+          <c:idx val="2"/>
+          <c:order val="2"/>
+          <c:tx>
+            <c:strRef>
+              <c:f>Sheet1!$D$1</c:f>
+              <c:strCache>
+                <c:ptCount val="1"/>
+              </c:strCache>
+            </c:strRef>
+          </c:tx>
+          <c:spPr>
+            <a:solidFill>
+              <a:schemeClr val="accent3"/>
+            </a:solidFill>
+            <a:ln>
+              <a:noFill/>
+            </a:ln>
+            <a:effectLst/>
+          </c:spPr>
+          <c:invertIfNegative val="0"/>
+          <c:cat>
+            <c:strRef>
+              <c:f>Sheet1!$A$2:$A$5</c:f>
+              <c:strCache>
+                <c:ptCount val="4"/>
+                <c:pt idx="0">
+                  <c:v>Fuel</c:v>
+                </c:pt>
+                <c:pt idx="1">
+                  <c:v>Labor</c:v>
+                </c:pt>
+                <c:pt idx="2">
+                  <c:v>Maintenance</c:v>
+                </c:pt>
+                <c:pt idx="3">
+                  <c:v>Other</c:v>
+                </c:pt>
+              </c:strCache>
+            </c:strRef>
+          </c:cat>
+          <c:val>
+            <c:numRef>
+              <c:f>Sheet1!$D$2:$D$5</c:f>
+              <c:numCache>
+                <c:formatCode>General</c:formatCode>
+                <c:ptCount val="4"/>
+              </c:numCache>
+            </c:numRef>
+          </c:val>
+          <c:extLst>
+            <c:ext xmlns:c16="http://schemas.microsoft.com/office/drawing/2014/chart" uri="{C3380CC4-5D6E-409C-BE32-E72D297353CC}">
+              <c16:uniqueId val="{00000002-4262-496B-8E51-EAD9C5FC3963}"/>
+            </c:ext>
+          </c:extLst>
+        </c:ser>
+        <c:dLbls>
+          <c:showLegendKey val="0"/>
+          <c:showVal val="0"/>
+          <c:showCatName val="0"/>
+          <c:showSerName val="0"/>
+          <c:showPercent val="0"/>
+          <c:showBubbleSize val="0"/>
+        </c:dLbls>
+        <c:gapWidth val="219"/>
+        <c:overlap val="-27"/>
+        <c:axId val="1009809871"/>
+        <c:axId val="1129237903"/>
+      </c:barChart>
+      <c:catAx>
+        <c:axId val="1009809871"/>
+        <c:scaling>
+          <c:orientation val="minMax"/>
+        </c:scaling>
+        <c:delete val="0"/>
+        <c:axPos val="b"/>
+        <c:numFmt formatCode="General" sourceLinked="1"/>
+        <c:majorTickMark val="none"/>
+        <c:minorTickMark val="none"/>
+        <c:tickLblPos val="nextTo"/>
+        <c:spPr>
+          <a:noFill/>
+          <a:ln w="9525" cap="flat" cmpd="sng" algn="ctr">
+            <a:solidFill>
+              <a:schemeClr val="tx1">
+                <a:lumMod val="15000"/>
+                <a:lumOff val="85000"/>
+              </a:schemeClr>
+            </a:solidFill>
+            <a:round/>
+          </a:ln>
+          <a:effectLst/>
+        </c:spPr>
+        <c:txPr>
+          <a:bodyPr rot="-60000000" spcFirstLastPara="1" vertOverflow="ellipsis" vert="horz" wrap="square" anchor="ctr" anchorCtr="1"/>
+          <a:lstStyle/>
+          <a:p>
+            <a:pPr>
+              <a:defRPr sz="1197" b="0" i="0" u="none" strike="noStrike" kern="1200" baseline="0">
+                <a:solidFill>
+                  <a:schemeClr val="tx1">
+                    <a:lumMod val="65000"/>
+                    <a:lumOff val="35000"/>
+                  </a:schemeClr>
+                </a:solidFill>
+                <a:latin typeface="+mn-lt"/>
+                <a:ea typeface="+mn-ea"/>
+                <a:cs typeface="+mn-cs"/>
+              </a:defRPr>
+            </a:pPr>
+            <a:endParaRPr lang="en-US"/>
+          </a:p>
+        </c:txPr>
+        <c:crossAx val="1129237903"/>
+        <c:crosses val="autoZero"/>
+        <c:auto val="1"/>
+        <c:lblAlgn val="ctr"/>
+        <c:lblOffset val="100"/>
+        <c:noMultiLvlLbl val="0"/>
+      </c:catAx>
+      <c:valAx>
+        <c:axId val="1129237903"/>
+        <c:scaling>
+          <c:orientation val="minMax"/>
+        </c:scaling>
+        <c:delete val="0"/>
+        <c:axPos val="l"/>
+        <c:majorGridlines>
+          <c:spPr>
+            <a:ln w="9525" cap="flat" cmpd="sng" algn="ctr">
+              <a:solidFill>
+                <a:schemeClr val="tx1">
+                  <a:lumMod val="15000"/>
+                  <a:lumOff val="85000"/>
+                </a:schemeClr>
+              </a:solidFill>
+              <a:round/>
+            </a:ln>
+            <a:effectLst/>
+          </c:spPr>
+        </c:majorGridlines>
+        <c:numFmt formatCode="General" sourceLinked="1"/>
+        <c:majorTickMark val="none"/>
+        <c:minorTickMark val="none"/>
+        <c:tickLblPos val="nextTo"/>
+        <c:spPr>
+          <a:noFill/>
+          <a:ln>
+            <a:noFill/>
+          </a:ln>
+          <a:effectLst/>
+        </c:spPr>
+        <c:txPr>
+          <a:bodyPr rot="-60000000" spcFirstLastPara="1" vertOverflow="ellipsis" vert="horz" wrap="square" anchor="ctr" anchorCtr="1"/>
+          <a:lstStyle/>
+          <a:p>
+            <a:pPr>
+              <a:defRPr sz="1197" b="0" i="0" u="none" strike="noStrike" kern="1200" baseline="0">
+                <a:solidFill>
+                  <a:schemeClr val="tx1">
+                    <a:lumMod val="65000"/>
+                    <a:lumOff val="35000"/>
+                  </a:schemeClr>
+                </a:solidFill>
+                <a:latin typeface="+mn-lt"/>
+                <a:ea typeface="+mn-ea"/>
+                <a:cs typeface="+mn-cs"/>
+              </a:defRPr>
+            </a:pPr>
+            <a:endParaRPr lang="en-US"/>
+          </a:p>
+        </c:txPr>
+        <c:crossAx val="1009809871"/>
+        <c:crosses val="autoZero"/>
+        <c:crossBetween val="between"/>
+      </c:valAx>
+      <c:spPr>
+        <a:noFill/>
+        <a:ln>
+          <a:noFill/>
+        </a:ln>
+        <a:effectLst/>
+      </c:spPr>
+    </c:plotArea>
+    <c:legend>
+      <c:legendPos val="b"/>
+      <c:overlay val="0"/>
+      <c:spPr>
+        <a:noFill/>
+        <a:ln>
+          <a:noFill/>
+        </a:ln>
+        <a:effectLst/>
+      </c:spPr>
+      <c:txPr>
+        <a:bodyPr rot="0" spcFirstLastPara="1" vertOverflow="ellipsis" vert="horz" wrap="square" anchor="ctr" anchorCtr="1"/>
+        <a:lstStyle/>
+        <a:p>
+          <a:pPr>
+            <a:defRPr sz="1197" b="0" i="0" u="none" strike="noStrike" kern="1200" baseline="0">
+              <a:solidFill>
+                <a:schemeClr val="tx1">
+                  <a:lumMod val="65000"/>
+                  <a:lumOff val="35000"/>
+                </a:schemeClr>
+              </a:solidFill>
+              <a:latin typeface="+mn-lt"/>
+              <a:ea typeface="+mn-ea"/>
+              <a:cs typeface="+mn-cs"/>
+            </a:defRPr>
+          </a:pPr>
+          <a:endParaRPr lang="en-US"/>
+        </a:p>
+      </c:txPr>
+    </c:legend>
+    <c:plotVisOnly val="1"/>
+    <c:dispBlanksAs val="gap"/>
+    <c:showDLblsOverMax val="0"/>
+    <c:extLst>
+      <c:ext xmlns:c16r3="http://schemas.microsoft.com/office/drawing/2017/03/chart" uri="{56B9EC1D-385E-4148-901F-78D8002777C0}">
+        <c16r3:dataDisplayOptions16>
+          <c16r3:dispNaAsBlank val="1"/>
+        </c16r3:dataDisplayOptions16>
+      </c:ext>
+    </c:extLst>
+  </c:chart>
+  <c:spPr>
+    <a:noFill/>
+    <a:ln>
+      <a:noFill/>
+    </a:ln>
+    <a:effectLst/>
+  </c:spPr>
+  <c:txPr>
+    <a:bodyPr/>
+    <a:lstStyle/>
+    <a:p>
+      <a:pPr>
+        <a:defRPr/>
+      </a:pPr>
+      <a:endParaRPr lang="en-US"/>
+    </a:p>
+  </c:txPr>
+  <c:externalData r:id="rId3">
+    <c:autoUpdate val="0"/>
+  </c:externalData>
+</c:chartSpace>
+</file>
+
+<file path=ppt/charts/chart3.xml><?xml version="1.0" encoding="utf-8"?>
+<c:chartSpace xmlns:c="http://schemas.openxmlformats.org/drawingml/2006/chart" xmlns:a="http://schemas.openxmlformats.org/drawingml/2006/main" xmlns:r="http://schemas.openxmlformats.org/officeDocument/2006/relationships" xmlns:c16r2="http://schemas.microsoft.com/office/drawing/2015/06/chart">
+  <c:date1904 val="0"/>
+  <c:lang val="en-US"/>
+  <c:roundedCorners val="0"/>
+  <mc:AlternateContent xmlns:mc="http://schemas.openxmlformats.org/markup-compatibility/2006">
+    <mc:Choice xmlns:c14="http://schemas.microsoft.com/office/drawing/2007/8/2/chart" Requires="c14">
+      <c14:style val="102"/>
+    </mc:Choice>
+    <mc:Fallback>
+      <c:style val="2"/>
+    </mc:Fallback>
+  </mc:AlternateContent>
+  <c:chart>
+    <c:title>
+      <c:tx>
+        <c:rich>
+          <a:bodyPr rot="0" spcFirstLastPara="1" vertOverflow="ellipsis" vert="horz" wrap="square" anchor="ctr" anchorCtr="1"/>
+          <a:lstStyle/>
+          <a:p>
+            <a:pPr>
+              <a:defRPr sz="1862" b="0" i="0" u="none" strike="noStrike" kern="1200" spc="0" baseline="0">
+                <a:solidFill>
+                  <a:schemeClr val="tx1">
+                    <a:lumMod val="65000"/>
+                    <a:lumOff val="35000"/>
+                  </a:schemeClr>
+                </a:solidFill>
+                <a:latin typeface="+mn-lt"/>
+                <a:ea typeface="+mn-ea"/>
+                <a:cs typeface="+mn-cs"/>
+              </a:defRPr>
+            </a:pPr>
+            <a:r>
+              <a:rPr lang="en-US" sz="1800" b="0" dirty="0">
+                <a:effectLst/>
+              </a:rPr>
+              <a:t>Sector Revenue</a:t>
+            </a:r>
+          </a:p>
+        </c:rich>
+      </c:tx>
+      <c:overlay val="0"/>
+      <c:spPr>
+        <a:noFill/>
+        <a:ln>
+          <a:noFill/>
+        </a:ln>
+        <a:effectLst/>
+      </c:spPr>
+      <c:txPr>
+        <a:bodyPr rot="0" spcFirstLastPara="1" vertOverflow="ellipsis" vert="horz" wrap="square" anchor="ctr" anchorCtr="1"/>
+        <a:lstStyle/>
+        <a:p>
+          <a:pPr>
+            <a:defRPr sz="1862" b="0" i="0" u="none" strike="noStrike" kern="1200" spc="0" baseline="0">
+              <a:solidFill>
+                <a:schemeClr val="tx1">
+                  <a:lumMod val="65000"/>
+                  <a:lumOff val="35000"/>
+                </a:schemeClr>
+              </a:solidFill>
+              <a:latin typeface="+mn-lt"/>
+              <a:ea typeface="+mn-ea"/>
+              <a:cs typeface="+mn-cs"/>
+            </a:defRPr>
+          </a:pPr>
+          <a:endParaRPr lang="en-US"/>
+        </a:p>
+      </c:txPr>
+    </c:title>
+    <c:autoTitleDeleted val="0"/>
+    <c:plotArea>
+      <c:layout/>
+      <c:barChart>
+        <c:barDir val="bar"/>
+        <c:grouping val="clustered"/>
+        <c:varyColors val="0"/>
+        <c:ser>
+          <c:idx val="0"/>
+          <c:order val="0"/>
+          <c:tx>
+            <c:strRef>
+              <c:f>Sheet1!$B$1</c:f>
+              <c:strCache>
+                <c:ptCount val="1"/>
+                <c:pt idx="0">
+                  <c:v>Revenue ($M)</c:v>
+                </c:pt>
+              </c:strCache>
+            </c:strRef>
+          </c:tx>
+          <c:spPr>
+            <a:solidFill>
+              <a:schemeClr val="accent1"/>
+            </a:solidFill>
+            <a:ln>
+              <a:noFill/>
+            </a:ln>
+            <a:effectLst/>
+          </c:spPr>
+          <c:invertIfNegative val="0"/>
+          <c:cat>
+            <c:strRef>
+              <c:f>Sheet1!$A$2:$A$6</c:f>
+              <c:strCache>
+                <c:ptCount val="5"/>
+                <c:pt idx="0">
+                  <c:v>North</c:v>
+                </c:pt>
+                <c:pt idx="1">
+                  <c:v>South</c:v>
+                </c:pt>
+                <c:pt idx="2">
+                  <c:v>East</c:v>
+                </c:pt>
+                <c:pt idx="3">
+                  <c:v>West</c:v>
+                </c:pt>
+                <c:pt idx="4">
+                  <c:v>Central</c:v>
+                </c:pt>
+              </c:strCache>
+            </c:strRef>
+          </c:cat>
+          <c:val>
+            <c:numRef>
+              <c:f>Sheet1!$B$2:$B$6</c:f>
+              <c:numCache>
+                <c:formatCode>General</c:formatCode>
+                <c:ptCount val="5"/>
+                <c:pt idx="0">
+                  <c:v>1.45</c:v>
+                </c:pt>
+                <c:pt idx="1">
+                  <c:v>0</c:v>
+                </c:pt>
+                <c:pt idx="2">
+                  <c:v>0</c:v>
+                </c:pt>
+                <c:pt idx="3">
+                  <c:v>0</c:v>
+                </c:pt>
+                <c:pt idx="4">
+                  <c:v>0</c:v>
+                </c:pt>
+              </c:numCache>
+            </c:numRef>
+          </c:val>
+          <c:extLst>
+            <c:ext xmlns:c16="http://schemas.microsoft.com/office/drawing/2014/chart" uri="{C3380CC4-5D6E-409C-BE32-E72D297353CC}">
+              <c16:uniqueId val="{00000000-DC63-4471-A330-8330265E64D1}"/>
+            </c:ext>
+          </c:extLst>
+        </c:ser>
+        <c:dLbls>
+          <c:showLegendKey val="0"/>
+          <c:showVal val="0"/>
+          <c:showCatName val="0"/>
+          <c:showSerName val="0"/>
+          <c:showPercent val="0"/>
+          <c:showBubbleSize val="0"/>
+        </c:dLbls>
+        <c:gapWidth val="182"/>
+        <c:axId val="1215136463"/>
+        <c:axId val="473443567"/>
+      </c:barChart>
+      <c:catAx>
+        <c:axId val="1215136463"/>
+        <c:scaling>
+          <c:orientation val="minMax"/>
+        </c:scaling>
+        <c:delete val="0"/>
+        <c:axPos val="l"/>
+        <c:numFmt formatCode="General" sourceLinked="1"/>
+        <c:majorTickMark val="none"/>
+        <c:minorTickMark val="none"/>
+        <c:tickLblPos val="nextTo"/>
+        <c:spPr>
+          <a:noFill/>
+          <a:ln w="9525" cap="flat" cmpd="sng" algn="ctr">
+            <a:solidFill>
+              <a:schemeClr val="tx1">
+                <a:lumMod val="15000"/>
+                <a:lumOff val="85000"/>
+              </a:schemeClr>
+            </a:solidFill>
+            <a:round/>
+          </a:ln>
+          <a:effectLst/>
+        </c:spPr>
+        <c:txPr>
+          <a:bodyPr rot="-60000000" spcFirstLastPara="1" vertOverflow="ellipsis" vert="horz" wrap="square" anchor="ctr" anchorCtr="1"/>
+          <a:lstStyle/>
+          <a:p>
+            <a:pPr>
+              <a:defRPr sz="1197" b="0" i="0" u="none" strike="noStrike" kern="1200" baseline="0">
+                <a:solidFill>
+                  <a:schemeClr val="tx1">
+                    <a:lumMod val="65000"/>
+                    <a:lumOff val="35000"/>
+                  </a:schemeClr>
+                </a:solidFill>
+                <a:latin typeface="+mn-lt"/>
+                <a:ea typeface="+mn-ea"/>
+                <a:cs typeface="+mn-cs"/>
+              </a:defRPr>
+            </a:pPr>
+            <a:endParaRPr lang="en-US"/>
+          </a:p>
+        </c:txPr>
+        <c:crossAx val="473443567"/>
+        <c:crosses val="autoZero"/>
+        <c:auto val="1"/>
+        <c:lblAlgn val="ctr"/>
+        <c:lblOffset val="100"/>
+        <c:noMultiLvlLbl val="0"/>
+      </c:catAx>
+      <c:valAx>
+        <c:axId val="473443567"/>
+        <c:scaling>
+          <c:orientation val="minMax"/>
+        </c:scaling>
+        <c:delete val="0"/>
+        <c:axPos val="b"/>
+        <c:majorGridlines>
+          <c:spPr>
+            <a:ln w="9525" cap="flat" cmpd="sng" algn="ctr">
+              <a:solidFill>
+                <a:schemeClr val="tx1">
+                  <a:lumMod val="15000"/>
+                  <a:lumOff val="85000"/>
+                </a:schemeClr>
+              </a:solidFill>
+              <a:round/>
+            </a:ln>
+            <a:effectLst/>
+          </c:spPr>
+        </c:majorGridlines>
+        <c:numFmt formatCode="General" sourceLinked="1"/>
+        <c:majorTickMark val="none"/>
+        <c:minorTickMark val="none"/>
+        <c:tickLblPos val="nextTo"/>
+        <c:spPr>
+          <a:noFill/>
+          <a:ln>
+            <a:noFill/>
+          </a:ln>
+          <a:effectLst/>
+        </c:spPr>
+        <c:txPr>
+          <a:bodyPr rot="-60000000" spcFirstLastPara="1" vertOverflow="ellipsis" vert="horz" wrap="square" anchor="ctr" anchorCtr="1"/>
+          <a:lstStyle/>
+          <a:p>
+            <a:pPr>
+              <a:defRPr sz="1197" b="0" i="0" u="none" strike="noStrike" kern="1200" baseline="0">
+                <a:solidFill>
+                  <a:schemeClr val="tx1">
+                    <a:lumMod val="65000"/>
+                    <a:lumOff val="35000"/>
+                  </a:schemeClr>
+                </a:solidFill>
+                <a:latin typeface="+mn-lt"/>
+                <a:ea typeface="+mn-ea"/>
+                <a:cs typeface="+mn-cs"/>
+              </a:defRPr>
+            </a:pPr>
+            <a:endParaRPr lang="en-US"/>
+          </a:p>
+        </c:txPr>
+        <c:crossAx val="1215136463"/>
+        <c:crosses val="autoZero"/>
+        <c:crossBetween val="between"/>
+      </c:valAx>
+      <c:spPr>
+        <a:noFill/>
+        <a:ln>
+          <a:noFill/>
+        </a:ln>
+        <a:effectLst/>
+      </c:spPr>
+    </c:plotArea>
+    <c:legend>
+      <c:legendPos val="b"/>
+      <c:overlay val="0"/>
+      <c:spPr>
+        <a:noFill/>
+        <a:ln>
+          <a:noFill/>
+        </a:ln>
+        <a:effectLst/>
+      </c:spPr>
+      <c:txPr>
+        <a:bodyPr rot="0" spcFirstLastPara="1" vertOverflow="ellipsis" vert="horz" wrap="square" anchor="ctr" anchorCtr="1"/>
+        <a:lstStyle/>
+        <a:p>
+          <a:pPr>
+            <a:defRPr sz="1197" b="0" i="0" u="none" strike="noStrike" kern="1200" baseline="0">
+              <a:solidFill>
+                <a:schemeClr val="tx1">
+                  <a:lumMod val="65000"/>
+                  <a:lumOff val="35000"/>
+                </a:schemeClr>
+              </a:solidFill>
+              <a:latin typeface="+mn-lt"/>
+              <a:ea typeface="+mn-ea"/>
+              <a:cs typeface="+mn-cs"/>
+            </a:defRPr>
+          </a:pPr>
+          <a:endParaRPr lang="en-US"/>
+        </a:p>
+      </c:txPr>
+    </c:legend>
+    <c:plotVisOnly val="1"/>
+    <c:dispBlanksAs val="gap"/>
+    <c:showDLblsOverMax val="0"/>
+    <c:extLst>
+      <c:ext xmlns:c16r3="http://schemas.microsoft.com/office/drawing/2017/03/chart" uri="{56B9EC1D-385E-4148-901F-78D8002777C0}">
+        <c16r3:dataDisplayOptions16>
+          <c16r3:dispNaAsBlank val="1"/>
+        </c16r3:dataDisplayOptions16>
+      </c:ext>
+    </c:extLst>
+  </c:chart>
+  <c:spPr>
+    <a:noFill/>
+    <a:ln>
+      <a:noFill/>
+    </a:ln>
+    <a:effectLst/>
+  </c:spPr>
+  <c:txPr>
+    <a:bodyPr/>
+    <a:lstStyle/>
+    <a:p>
+      <a:pPr>
+        <a:defRPr/>
+      </a:pPr>
+      <a:endParaRPr lang="en-US"/>
+    </a:p>
+  </c:txPr>
+  <c:externalData r:id="rId3">
+    <c:autoUpdate val="0"/>
+  </c:externalData>
+</c:chartSpace>
+</file>
+
+<file path=ppt/charts/colors1.xml><?xml version="1.0" encoding="utf-8"?>
+<cs:colorStyle xmlns:cs="http://schemas.microsoft.com/office/drawing/2012/chartStyle" xmlns:a="http://schemas.openxmlformats.org/drawingml/2006/main" meth="cycle" id="10">
+  <a:schemeClr val="accent1"/>
+  <a:schemeClr val="accent2"/>
+  <a:schemeClr val="accent3"/>
+  <a:schemeClr val="accent4"/>
+  <a:schemeClr val="accent5"/>
+  <a:schemeClr val="accent6"/>
+  <cs:variation/>
+  <cs:variation>
+    <a:lumMod val="60000"/>
+  </cs:variation>
+  <cs:variation>
+    <a:lumMod val="80000"/>
+    <a:lumOff val="20000"/>
+  </cs:variation>
+  <cs:variation>
+    <a:lumMod val="80000"/>
+  </cs:variation>
+  <cs:variation>
+    <a:lumMod val="60000"/>
+    <a:lumOff val="40000"/>
+  </cs:variation>
+  <cs:variation>
+    <a:lumMod val="50000"/>
+  </cs:variation>
+  <cs:variation>
+    <a:lumMod val="70000"/>
+    <a:lumOff val="30000"/>
+  </cs:variation>
+  <cs:variation>
+    <a:lumMod val="70000"/>
+  </cs:variation>
+  <cs:variation>
+    <a:lumMod val="50000"/>
+    <a:lumOff val="50000"/>
+  </cs:variation>
+</cs:colorStyle>
+</file>
+
+<file path=ppt/charts/colors2.xml><?xml version="1.0" encoding="utf-8"?>
+<cs:colorStyle xmlns:cs="http://schemas.microsoft.com/office/drawing/2012/chartStyle" xmlns:a="http://schemas.openxmlformats.org/drawingml/2006/main" meth="cycle" id="10">
+  <a:schemeClr val="accent1"/>
+  <a:schemeClr val="accent2"/>
+  <a:schemeClr val="accent3"/>
+  <a:schemeClr val="accent4"/>
+  <a:schemeClr val="accent5"/>
+  <a:schemeClr val="accent6"/>
+  <cs:variation/>
+  <cs:variation>
+    <a:lumMod val="60000"/>
+  </cs:variation>
+  <cs:variation>
+    <a:lumMod val="80000"/>
+    <a:lumOff val="20000"/>
+  </cs:variation>
+  <cs:variation>
+    <a:lumMod val="80000"/>
+  </cs:variation>
+  <cs:variation>
+    <a:lumMod val="60000"/>
+    <a:lumOff val="40000"/>
+  </cs:variation>
+  <cs:variation>
+    <a:lumMod val="50000"/>
+  </cs:variation>
+  <cs:variation>
+    <a:lumMod val="70000"/>
+    <a:lumOff val="30000"/>
+  </cs:variation>
+  <cs:variation>
+    <a:lumMod val="70000"/>
+  </cs:variation>
+  <cs:variation>
+    <a:lumMod val="50000"/>
+    <a:lumOff val="50000"/>
+  </cs:variation>
+</cs:colorStyle>
+</file>
+
+<file path=ppt/charts/colors3.xml><?xml version="1.0" encoding="utf-8"?>
+<cs:colorStyle xmlns:cs="http://schemas.microsoft.com/office/drawing/2012/chartStyle" xmlns:a="http://schemas.openxmlformats.org/drawingml/2006/main" meth="cycle" id="10">
+  <a:schemeClr val="accent1"/>
+  <a:schemeClr val="accent2"/>
+  <a:schemeClr val="accent3"/>
+  <a:schemeClr val="accent4"/>
+  <a:schemeClr val="accent5"/>
+  <a:schemeClr val="accent6"/>
+  <cs:variation/>
+  <cs:variation>
+    <a:lumMod val="60000"/>
+  </cs:variation>
+  <cs:variation>
+    <a:lumMod val="80000"/>
+    <a:lumOff val="20000"/>
+  </cs:variation>
+  <cs:variation>
+    <a:lumMod val="80000"/>
+  </cs:variation>
+  <cs:variation>
+    <a:lumMod val="60000"/>
+    <a:lumOff val="40000"/>
+  </cs:variation>
+  <cs:variation>
+    <a:lumMod val="50000"/>
+  </cs:variation>
+  <cs:variation>
+    <a:lumMod val="70000"/>
+    <a:lumOff val="30000"/>
+  </cs:variation>
+  <cs:variation>
+    <a:lumMod val="70000"/>
+  </cs:variation>
+  <cs:variation>
+    <a:lumMod val="50000"/>
+    <a:lumOff val="50000"/>
+  </cs:variation>
+</cs:colorStyle>
+</file>
+
+<file path=ppt/charts/style1.xml><?xml version="1.0" encoding="utf-8"?>
+<cs:chartStyle xmlns:cs="http://schemas.microsoft.com/office/drawing/2012/chartStyle" xmlns:a="http://schemas.openxmlformats.org/drawingml/2006/main" id="227">
+  <cs:axisTitle>
+    <cs:lnRef idx="0"/>
+    <cs:fillRef idx="0"/>
+    <cs:effectRef idx="0"/>
+    <cs:fontRef idx="minor">
+      <a:schemeClr val="tx1">
+        <a:lumMod val="65000"/>
+        <a:lumOff val="35000"/>
+      </a:schemeClr>
+    </cs:fontRef>
+    <cs:defRPr sz="1330" kern="1200"/>
+  </cs:axisTitle>
+  <cs:categoryAxis>
+    <cs:lnRef idx="0"/>
+    <cs:fillRef idx="0"/>
+    <cs:effectRef idx="0"/>
+    <cs:fontRef idx="minor">
+      <a:schemeClr val="tx1">
+        <a:lumMod val="65000"/>
+        <a:lumOff val="35000"/>
+      </a:schemeClr>
+    </cs:fontRef>
+    <cs:spPr>
+      <a:ln w="9525" cap="flat" cmpd="sng" algn="ctr">
+        <a:solidFill>
+          <a:schemeClr val="tx1">
+            <a:lumMod val="15000"/>
+            <a:lumOff val="85000"/>
+          </a:schemeClr>
+        </a:solidFill>
+        <a:round/>
+      </a:ln>
+    </cs:spPr>
+    <cs:defRPr sz="1197" kern="1200"/>
+  </cs:categoryAxis>
+  <cs:chartArea mods="allowNoFillOverride allowNoLineOverride">
+    <cs:lnRef idx="0"/>
+    <cs:fillRef idx="0"/>
+    <cs:effectRef idx="0"/>
+    <cs:fontRef idx="minor">
+      <a:schemeClr val="tx1"/>
+    </cs:fontRef>
+    <cs:spPr>
+      <a:solidFill>
+        <a:schemeClr val="bg1"/>
+      </a:solidFill>
+      <a:ln w="9525" cap="flat" cmpd="sng" algn="ctr">
+        <a:solidFill>
+          <a:schemeClr val="tx1">
+            <a:lumMod val="15000"/>
+            <a:lumOff val="85000"/>
+          </a:schemeClr>
+        </a:solidFill>
+        <a:round/>
+      </a:ln>
+    </cs:spPr>
+    <cs:defRPr sz="1330" kern="1200"/>
+  </cs:chartArea>
+  <cs:dataLabel>
+    <cs:lnRef idx="0"/>
+    <cs:fillRef idx="0"/>
+    <cs:effectRef idx="0"/>
+    <cs:fontRef idx="minor">
+      <a:schemeClr val="tx1">
+        <a:lumMod val="75000"/>
+        <a:lumOff val="25000"/>
+      </a:schemeClr>
+    </cs:fontRef>
+    <cs:defRPr sz="1197" kern="1200"/>
+  </cs:dataLabel>
+  <cs:dataLabelCallout>
+    <cs:lnRef idx="0"/>
+    <cs:fillRef idx="0"/>
+    <cs:effectRef idx="0"/>
+    <cs:fontRef idx="minor">
+      <a:schemeClr val="dk1">
+        <a:lumMod val="65000"/>
+        <a:lumOff val="35000"/>
+      </a:schemeClr>
+    </cs:fontRef>
+    <cs:spPr>
+      <a:solidFill>
+        <a:schemeClr val="lt1"/>
+      </a:solidFill>
+      <a:ln>
+        <a:solidFill>
+          <a:schemeClr val="dk1">
+            <a:lumMod val="25000"/>
+            <a:lumOff val="75000"/>
+          </a:schemeClr>
+        </a:solidFill>
+      </a:ln>
+    </cs:spPr>
+    <cs:defRPr sz="1197" kern="1200"/>
+    <cs:bodyPr rot="0" spcFirstLastPara="1" vertOverflow="clip" horzOverflow="clip" vert="horz" wrap="square" lIns="36576" tIns="18288" rIns="36576" bIns="18288" anchor="ctr" anchorCtr="1">
+      <a:spAutoFit/>
+    </cs:bodyPr>
+  </cs:dataLabelCallout>
+  <cs:dataPoint>
+    <cs:lnRef idx="0"/>
+    <cs:fillRef idx="1">
+      <cs:styleClr val="auto"/>
+    </cs:fillRef>
+    <cs:effectRef idx="0"/>
+    <cs:fontRef idx="minor">
+      <a:schemeClr val="tx1"/>
+    </cs:fontRef>
+    <cs:spPr>
+      <a:solidFill>
+        <a:schemeClr val="phClr"/>
+      </a:solidFill>
+    </cs:spPr>
+  </cs:dataPoint>
+  <cs:dataPoint3D>
+    <cs:lnRef idx="0"/>
+    <cs:fillRef idx="1">
+      <cs:styleClr val="auto"/>
+    </cs:fillRef>
+    <cs:effectRef idx="0"/>
+    <cs:fontRef idx="minor">
+      <a:schemeClr val="tx1"/>
+    </cs:fontRef>
+    <cs:spPr>
+      <a:solidFill>
+        <a:schemeClr val="phClr"/>
+      </a:solidFill>
+    </cs:spPr>
+  </cs:dataPoint3D>
+  <cs:dataPointLine>
+    <cs:lnRef idx="0">
+      <cs:styleClr val="auto"/>
+    </cs:lnRef>
+    <cs:fillRef idx="1"/>
+    <cs:effectRef idx="0"/>
+    <cs:fontRef idx="minor">
+      <a:schemeClr val="tx1"/>
+    </cs:fontRef>
+    <cs:spPr>
+      <a:ln w="28575" cap="rnd">
+        <a:solidFill>
+          <a:schemeClr val="phClr"/>
+        </a:solidFill>
+        <a:round/>
+      </a:ln>
+    </cs:spPr>
+  </cs:dataPointLine>
+  <cs:dataPointMarker>
+    <cs:lnRef idx="0">
+      <cs:styleClr val="auto"/>
+    </cs:lnRef>
+    <cs:fillRef idx="1">
+      <cs:styleClr val="auto"/>
+    </cs:fillRef>
+    <cs:effectRef idx="0"/>
+    <cs:fontRef idx="minor">
+      <a:schemeClr val="tx1"/>
+    </cs:fontRef>
+    <cs:spPr>
+      <a:solidFill>
+        <a:schemeClr val="phClr"/>
+      </a:solidFill>
+      <a:ln w="9525">
+        <a:solidFill>
+          <a:schemeClr val="phClr"/>
+        </a:solidFill>
+      </a:ln>
+    </cs:spPr>
+  </cs:dataPointMarker>
+  <cs:dataPointMarkerLayout symbol="circle" size="5"/>
+  <cs:dataPointWireframe>
+    <cs:lnRef idx="0">
+      <cs:styleClr val="auto"/>
+    </cs:lnRef>
+    <cs:fillRef idx="1"/>
+    <cs:effectRef idx="0"/>
+    <cs:fontRef idx="minor">
+      <a:schemeClr val="tx1"/>
+    </cs:fontRef>
+    <cs:spPr>
+      <a:ln w="9525" cap="rnd">
+        <a:solidFill>
+          <a:schemeClr val="phClr"/>
+        </a:solidFill>
+        <a:round/>
+      </a:ln>
+    </cs:spPr>
+  </cs:dataPointWireframe>
+  <cs:dataTable>
+    <cs:lnRef idx="0"/>
+    <cs:fillRef idx="0"/>
+    <cs:effectRef idx="0"/>
+    <cs:fontRef idx="minor">
+      <a:schemeClr val="tx1">
+        <a:lumMod val="65000"/>
+        <a:lumOff val="35000"/>
+      </a:schemeClr>
+    </cs:fontRef>
+    <cs:spPr>
+      <a:noFill/>
+      <a:ln w="9525" cap="flat" cmpd="sng" algn="ctr">
+        <a:solidFill>
+          <a:schemeClr val="tx1">
+            <a:lumMod val="15000"/>
+            <a:lumOff val="85000"/>
+          </a:schemeClr>
+        </a:solidFill>
+        <a:round/>
+      </a:ln>
+    </cs:spPr>
+    <cs:defRPr sz="1197" kern="1200"/>
+  </cs:dataTable>
+  <cs:downBar>
+    <cs:lnRef idx="0"/>
+    <cs:fillRef idx="0"/>
+    <cs:effectRef idx="0"/>
+    <cs:fontRef idx="minor">
+      <a:schemeClr val="dk1"/>
+    </cs:fontRef>
+    <cs:spPr>
+      <a:solidFill>
+        <a:schemeClr val="dk1">
+          <a:lumMod val="65000"/>
+          <a:lumOff val="35000"/>
+        </a:schemeClr>
+      </a:solidFill>
+      <a:ln w="9525">
+        <a:solidFill>
+          <a:schemeClr val="tx1">
+            <a:lumMod val="65000"/>
+            <a:lumOff val="35000"/>
+          </a:schemeClr>
+        </a:solidFill>
+      </a:ln>
+    </cs:spPr>
+  </cs:downBar>
+  <cs:dropLine>
+    <cs:lnRef idx="0"/>
+    <cs:fillRef idx="0"/>
+    <cs:effectRef idx="0"/>
+    <cs:fontRef idx="minor">
+      <a:schemeClr val="tx1"/>
+    </cs:fontRef>
+    <cs:spPr>
+      <a:ln w="9525" cap="flat" cmpd="sng" algn="ctr">
+        <a:solidFill>
+          <a:schemeClr val="tx1">
+            <a:lumMod val="35000"/>
+            <a:lumOff val="65000"/>
+          </a:schemeClr>
+        </a:solidFill>
+        <a:round/>
+      </a:ln>
+    </cs:spPr>
+  </cs:dropLine>
+  <cs:errorBar>
+    <cs:lnRef idx="0"/>
+    <cs:fillRef idx="0"/>
+    <cs:effectRef idx="0"/>
+    <cs:fontRef idx="minor">
+      <a:schemeClr val="tx1"/>
+    </cs:fontRef>
+    <cs:spPr>
+      <a:ln w="9525" cap="flat" cmpd="sng" algn="ctr">
+        <a:solidFill>
+          <a:schemeClr val="tx1">
+            <a:lumMod val="65000"/>
+            <a:lumOff val="35000"/>
+          </a:schemeClr>
+        </a:solidFill>
+        <a:round/>
+      </a:ln>
+    </cs:spPr>
+  </cs:errorBar>
+  <cs:floor>
+    <cs:lnRef idx="0"/>
+    <cs:fillRef idx="0"/>
+    <cs:effectRef idx="0"/>
+    <cs:fontRef idx="minor">
+      <a:schemeClr val="tx1"/>
+    </cs:fontRef>
+    <cs:spPr>
+      <a:noFill/>
+      <a:ln>
+        <a:noFill/>
+      </a:ln>
+    </cs:spPr>
+  </cs:floor>
+  <cs:gridlineMajor>
+    <cs:lnRef idx="0"/>
+    <cs:fillRef idx="0"/>
+    <cs:effectRef idx="0"/>
+    <cs:fontRef idx="minor">
+      <a:schemeClr val="tx1"/>
+    </cs:fontRef>
+    <cs:spPr>
+      <a:ln w="9525" cap="flat" cmpd="sng" algn="ctr">
+        <a:solidFill>
+          <a:schemeClr val="tx1">
+            <a:lumMod val="15000"/>
+            <a:lumOff val="85000"/>
+          </a:schemeClr>
+        </a:solidFill>
+        <a:round/>
+      </a:ln>
+    </cs:spPr>
+  </cs:gridlineMajor>
+  <cs:gridlineMinor>
+    <cs:lnRef idx="0"/>
+    <cs:fillRef idx="0"/>
+    <cs:effectRef idx="0"/>
+    <cs:fontRef idx="minor">
+      <a:schemeClr val="tx1"/>
+    </cs:fontRef>
+    <cs:spPr>
+      <a:ln w="9525" cap="flat" cmpd="sng" algn="ctr">
+        <a:solidFill>
+          <a:schemeClr val="tx1">
+            <a:lumMod val="5000"/>
+            <a:lumOff val="95000"/>
+          </a:schemeClr>
+        </a:solidFill>
+        <a:round/>
+      </a:ln>
+    </cs:spPr>
+  </cs:gridlineMinor>
+  <cs:hiLoLine>
+    <cs:lnRef idx="0"/>
+    <cs:fillRef idx="0"/>
+    <cs:effectRef idx="0"/>
+    <cs:fontRef idx="minor">
+      <a:schemeClr val="tx1"/>
+    </cs:fontRef>
+    <cs:spPr>
+      <a:ln w="9525" cap="flat" cmpd="sng" algn="ctr">
+        <a:solidFill>
+          <a:schemeClr val="tx1">
+            <a:lumMod val="75000"/>
+            <a:lumOff val="25000"/>
+          </a:schemeClr>
+        </a:solidFill>
+        <a:round/>
+      </a:ln>
+    </cs:spPr>
+  </cs:hiLoLine>
+  <cs:leaderLine>
+    <cs:lnRef idx="0"/>
+    <cs:fillRef idx="0"/>
+    <cs:effectRef idx="0"/>
+    <cs:fontRef idx="minor">
+      <a:schemeClr val="tx1"/>
+    </cs:fontRef>
+    <cs:spPr>
+      <a:ln w="9525" cap="flat" cmpd="sng" algn="ctr">
+        <a:solidFill>
+          <a:schemeClr val="tx1">
+            <a:lumMod val="35000"/>
+            <a:lumOff val="65000"/>
+          </a:schemeClr>
+        </a:solidFill>
+        <a:round/>
+      </a:ln>
+    </cs:spPr>
+  </cs:leaderLine>
+  <cs:legend>
+    <cs:lnRef idx="0"/>
+    <cs:fillRef idx="0"/>
+    <cs:effectRef idx="0"/>
+    <cs:fontRef idx="minor">
+      <a:schemeClr val="tx1">
+        <a:lumMod val="65000"/>
+        <a:lumOff val="35000"/>
+      </a:schemeClr>
+    </cs:fontRef>
+    <cs:defRPr sz="1197" kern="1200"/>
+  </cs:legend>
+  <cs:plotArea mods="allowNoFillOverride allowNoLineOverride">
+    <cs:lnRef idx="0"/>
+    <cs:fillRef idx="0"/>
+    <cs:effectRef idx="0"/>
+    <cs:fontRef idx="minor">
+      <a:schemeClr val="tx1"/>
+    </cs:fontRef>
+  </cs:plotArea>
+  <cs:plotArea3D mods="allowNoFillOverride allowNoLineOverride">
+    <cs:lnRef idx="0"/>
+    <cs:fillRef idx="0"/>
+    <cs:effectRef idx="0"/>
+    <cs:fontRef idx="minor">
+      <a:schemeClr val="tx1"/>
+    </cs:fontRef>
+  </cs:plotArea3D>
+  <cs:seriesAxis>
+    <cs:lnRef idx="0"/>
+    <cs:fillRef idx="0"/>
+    <cs:effectRef idx="0"/>
+    <cs:fontRef idx="minor">
+      <a:schemeClr val="tx1">
+        <a:lumMod val="65000"/>
+        <a:lumOff val="35000"/>
+      </a:schemeClr>
+    </cs:fontRef>
+    <cs:defRPr sz="1197" kern="1200"/>
+  </cs:seriesAxis>
+  <cs:seriesLine>
+    <cs:lnRef idx="0"/>
+    <cs:fillRef idx="0"/>
+    <cs:effectRef idx="0"/>
+    <cs:fontRef idx="minor">
+      <a:schemeClr val="tx1"/>
+    </cs:fontRef>
+    <cs:spPr>
+      <a:ln w="9525" cap="flat" cmpd="sng" algn="ctr">
+        <a:solidFill>
+          <a:schemeClr val="tx1">
+            <a:lumMod val="35000"/>
+            <a:lumOff val="65000"/>
+          </a:schemeClr>
+        </a:solidFill>
+        <a:round/>
+      </a:ln>
+    </cs:spPr>
+  </cs:seriesLine>
+  <cs:title>
+    <cs:lnRef idx="0"/>
+    <cs:fillRef idx="0"/>
+    <cs:effectRef idx="0"/>
+    <cs:fontRef idx="minor">
+      <a:schemeClr val="tx1">
+        <a:lumMod val="65000"/>
+        <a:lumOff val="35000"/>
+      </a:schemeClr>
+    </cs:fontRef>
+    <cs:defRPr sz="1862" b="0" kern="1200" spc="0" baseline="0"/>
+  </cs:title>
+  <cs:trendline>
+    <cs:lnRef idx="0">
+      <cs:styleClr val="auto"/>
+    </cs:lnRef>
+    <cs:fillRef idx="0"/>
+    <cs:effectRef idx="0"/>
+    <cs:fontRef idx="minor">
+      <a:schemeClr val="tx1"/>
+    </cs:fontRef>
+    <cs:spPr>
+      <a:ln w="19050" cap="rnd">
+        <a:solidFill>
+          <a:schemeClr val="phClr"/>
+        </a:solidFill>
+        <a:prstDash val="sysDot"/>
+      </a:ln>
+    </cs:spPr>
+  </cs:trendline>
+  <cs:trendlineLabel>
+    <cs:lnRef idx="0"/>
+    <cs:fillRef idx="0"/>
+    <cs:effectRef idx="0"/>
+    <cs:fontRef idx="minor">
+      <a:schemeClr val="tx1">
+        <a:lumMod val="65000"/>
+        <a:lumOff val="35000"/>
+      </a:schemeClr>
+    </cs:fontRef>
+    <cs:defRPr sz="1197" kern="1200"/>
+  </cs:trendlineLabel>
+  <cs:upBar>
+    <cs:lnRef idx="0"/>
+    <cs:fillRef idx="0"/>
+    <cs:effectRef idx="0"/>
+    <cs:fontRef idx="minor">
+      <a:schemeClr val="dk1"/>
+    </cs:fontRef>
+    <cs:spPr>
+      <a:solidFill>
+        <a:schemeClr val="lt1"/>
+      </a:solidFill>
+      <a:ln w="9525">
+        <a:solidFill>
+          <a:schemeClr val="tx1">
+            <a:lumMod val="15000"/>
+            <a:lumOff val="85000"/>
+          </a:schemeClr>
+        </a:solidFill>
+      </a:ln>
+    </cs:spPr>
+  </cs:upBar>
+  <cs:valueAxis>
+    <cs:lnRef idx="0"/>
+    <cs:fillRef idx="0"/>
+    <cs:effectRef idx="0"/>
+    <cs:fontRef idx="minor">
+      <a:schemeClr val="tx1">
+        <a:lumMod val="65000"/>
+        <a:lumOff val="35000"/>
+      </a:schemeClr>
+    </cs:fontRef>
+    <cs:defRPr sz="1197" kern="1200"/>
+  </cs:valueAxis>
+  <cs:wall>
+    <cs:lnRef idx="0"/>
+    <cs:fillRef idx="0"/>
+    <cs:effectRef idx="0"/>
+    <cs:fontRef idx="minor">
+      <a:schemeClr val="tx1"/>
+    </cs:fontRef>
+    <cs:spPr>
+      <a:noFill/>
+      <a:ln>
+        <a:noFill/>
+      </a:ln>
+    </cs:spPr>
+  </cs:wall>
+</cs:chartStyle>
+</file>
+
+<file path=ppt/charts/style2.xml><?xml version="1.0" encoding="utf-8"?>
+<cs:chartStyle xmlns:cs="http://schemas.microsoft.com/office/drawing/2012/chartStyle" xmlns:a="http://schemas.openxmlformats.org/drawingml/2006/main" id="201">
+  <cs:axisTitle>
+    <cs:lnRef idx="0"/>
+    <cs:fillRef idx="0"/>
+    <cs:effectRef idx="0"/>
+    <cs:fontRef idx="minor">
+      <a:schemeClr val="tx1">
+        <a:lumMod val="65000"/>
+        <a:lumOff val="35000"/>
+      </a:schemeClr>
+    </cs:fontRef>
+    <cs:defRPr sz="1330" kern="1200"/>
+  </cs:axisTitle>
+  <cs:categoryAxis>
+    <cs:lnRef idx="0"/>
+    <cs:fillRef idx="0"/>
+    <cs:effectRef idx="0"/>
+    <cs:fontRef idx="minor">
+      <a:schemeClr val="tx1">
+        <a:lumMod val="65000"/>
+        <a:lumOff val="35000"/>
+      </a:schemeClr>
+    </cs:fontRef>
+    <cs:spPr>
+      <a:ln w="9525" cap="flat" cmpd="sng" algn="ctr">
+        <a:solidFill>
+          <a:schemeClr val="tx1">
+            <a:lumMod val="15000"/>
+            <a:lumOff val="85000"/>
+          </a:schemeClr>
+        </a:solidFill>
+        <a:round/>
+      </a:ln>
+    </cs:spPr>
+    <cs:defRPr sz="1197" kern="1200"/>
+  </cs:categoryAxis>
+  <cs:chartArea mods="allowNoFillOverride allowNoLineOverride">
+    <cs:lnRef idx="0"/>
+    <cs:fillRef idx="0"/>
+    <cs:effectRef idx="0"/>
+    <cs:fontRef idx="minor">
+      <a:schemeClr val="tx1"/>
+    </cs:fontRef>
+    <cs:spPr>
+      <a:solidFill>
+        <a:schemeClr val="bg1"/>
+      </a:solidFill>
+      <a:ln w="9525" cap="flat" cmpd="sng" algn="ctr">
+        <a:solidFill>
+          <a:schemeClr val="tx1">
+            <a:lumMod val="15000"/>
+            <a:lumOff val="85000"/>
+          </a:schemeClr>
+        </a:solidFill>
+        <a:round/>
+      </a:ln>
+    </cs:spPr>
+    <cs:defRPr sz="1330" kern="1200"/>
+  </cs:chartArea>
+  <cs:dataLabel>
+    <cs:lnRef idx="0"/>
+    <cs:fillRef idx="0"/>
+    <cs:effectRef idx="0"/>
+    <cs:fontRef idx="minor">
+      <a:schemeClr val="tx1">
+        <a:lumMod val="75000"/>
+        <a:lumOff val="25000"/>
+      </a:schemeClr>
+    </cs:fontRef>
+    <cs:defRPr sz="1197" kern="1200"/>
+  </cs:dataLabel>
+  <cs:dataLabelCallout>
+    <cs:lnRef idx="0"/>
+    <cs:fillRef idx="0"/>
+    <cs:effectRef idx="0"/>
+    <cs:fontRef idx="minor">
+      <a:schemeClr val="dk1">
+        <a:lumMod val="65000"/>
+        <a:lumOff val="35000"/>
+      </a:schemeClr>
+    </cs:fontRef>
+    <cs:spPr>
+      <a:solidFill>
+        <a:schemeClr val="lt1"/>
+      </a:solidFill>
+      <a:ln>
+        <a:solidFill>
+          <a:schemeClr val="dk1">
+            <a:lumMod val="25000"/>
+            <a:lumOff val="75000"/>
+          </a:schemeClr>
+        </a:solidFill>
+      </a:ln>
+    </cs:spPr>
+    <cs:defRPr sz="1197" kern="1200"/>
+    <cs:bodyPr rot="0" spcFirstLastPara="1" vertOverflow="clip" horzOverflow="clip" vert="horz" wrap="square" lIns="36576" tIns="18288" rIns="36576" bIns="18288" anchor="ctr" anchorCtr="1">
+      <a:spAutoFit/>
+    </cs:bodyPr>
+  </cs:dataLabelCallout>
+  <cs:dataPoint>
+    <cs:lnRef idx="0"/>
+    <cs:fillRef idx="1">
+      <cs:styleClr val="auto"/>
+    </cs:fillRef>
+    <cs:effectRef idx="0"/>
+    <cs:fontRef idx="minor">
+      <a:schemeClr val="tx1"/>
+    </cs:fontRef>
+  </cs:dataPoint>
+  <cs:dataPoint3D>
+    <cs:lnRef idx="0"/>
+    <cs:fillRef idx="1">
+      <cs:styleClr val="auto"/>
+    </cs:fillRef>
+    <cs:effectRef idx="0"/>
+    <cs:fontRef idx="minor">
+      <a:schemeClr val="tx1"/>
+    </cs:fontRef>
+  </cs:dataPoint3D>
+  <cs:dataPointLine>
+    <cs:lnRef idx="0">
+      <cs:styleClr val="auto"/>
+    </cs:lnRef>
+    <cs:fillRef idx="1"/>
+    <cs:effectRef idx="0"/>
+    <cs:fontRef idx="minor">
+      <a:schemeClr val="tx1"/>
+    </cs:fontRef>
+    <cs:spPr>
+      <a:ln w="28575" cap="rnd">
+        <a:solidFill>
+          <a:schemeClr val="phClr"/>
+        </a:solidFill>
+        <a:round/>
+      </a:ln>
+    </cs:spPr>
+  </cs:dataPointLine>
+  <cs:dataPointMarker>
+    <cs:lnRef idx="0">
+      <cs:styleClr val="auto"/>
+    </cs:lnRef>
+    <cs:fillRef idx="1">
+      <cs:styleClr val="auto"/>
+    </cs:fillRef>
+    <cs:effectRef idx="0"/>
+    <cs:fontRef idx="minor">
+      <a:schemeClr val="tx1"/>
+    </cs:fontRef>
+    <cs:spPr>
+      <a:ln w="9525">
+        <a:solidFill>
+          <a:schemeClr val="phClr"/>
+        </a:solidFill>
+      </a:ln>
+    </cs:spPr>
+  </cs:dataPointMarker>
+  <cs:dataPointMarkerLayout symbol="circle" size="5"/>
+  <cs:dataPointWireframe>
+    <cs:lnRef idx="0">
+      <cs:styleClr val="auto"/>
+    </cs:lnRef>
+    <cs:fillRef idx="1"/>
+    <cs:effectRef idx="0"/>
+    <cs:fontRef idx="minor">
+      <a:schemeClr val="tx1"/>
+    </cs:fontRef>
+    <cs:spPr>
+      <a:ln w="9525" cap="rnd">
+        <a:solidFill>
+          <a:schemeClr val="phClr"/>
+        </a:solidFill>
+        <a:round/>
+      </a:ln>
+    </cs:spPr>
+  </cs:dataPointWireframe>
+  <cs:dataTable>
+    <cs:lnRef idx="0"/>
+    <cs:fillRef idx="0"/>
+    <cs:effectRef idx="0"/>
+    <cs:fontRef idx="minor">
+      <a:schemeClr val="tx1">
+        <a:lumMod val="65000"/>
+        <a:lumOff val="35000"/>
+      </a:schemeClr>
+    </cs:fontRef>
+    <cs:spPr>
+      <a:noFill/>
+      <a:ln w="9525" cap="flat" cmpd="sng" algn="ctr">
+        <a:solidFill>
+          <a:schemeClr val="tx1">
+            <a:lumMod val="15000"/>
+            <a:lumOff val="85000"/>
+          </a:schemeClr>
+        </a:solidFill>
+        <a:round/>
+      </a:ln>
+    </cs:spPr>
+    <cs:defRPr sz="1197" kern="1200"/>
+  </cs:dataTable>
+  <cs:downBar>
+    <cs:lnRef idx="0"/>
+    <cs:fillRef idx="0"/>
+    <cs:effectRef idx="0"/>
+    <cs:fontRef idx="minor">
+      <a:schemeClr val="dk1"/>
+    </cs:fontRef>
+    <cs:spPr>
+      <a:solidFill>
+        <a:schemeClr val="dk1">
+          <a:lumMod val="65000"/>
+          <a:lumOff val="35000"/>
+        </a:schemeClr>
+      </a:solidFill>
+      <a:ln w="9525">
+        <a:solidFill>
+          <a:schemeClr val="tx1">
+            <a:lumMod val="65000"/>
+            <a:lumOff val="35000"/>
+          </a:schemeClr>
+        </a:solidFill>
+      </a:ln>
+    </cs:spPr>
+  </cs:downBar>
+  <cs:dropLine>
+    <cs:lnRef idx="0"/>
+    <cs:fillRef idx="0"/>
+    <cs:effectRef idx="0"/>
+    <cs:fontRef idx="minor">
+      <a:schemeClr val="tx1"/>
+    </cs:fontRef>
+    <cs:spPr>
+      <a:ln w="9525" cap="flat" cmpd="sng" algn="ctr">
+        <a:solidFill>
+          <a:schemeClr val="tx1">
+            <a:lumMod val="35000"/>
+            <a:lumOff val="65000"/>
+          </a:schemeClr>
+        </a:solidFill>
+        <a:round/>
+      </a:ln>
+    </cs:spPr>
+  </cs:dropLine>
+  <cs:errorBar>
+    <cs:lnRef idx="0"/>
+    <cs:fillRef idx="0"/>
+    <cs:effectRef idx="0"/>
+    <cs:fontRef idx="minor">
+      <a:schemeClr val="tx1"/>
+    </cs:fontRef>
+    <cs:spPr>
+      <a:ln w="9525" cap="flat" cmpd="sng" algn="ctr">
+        <a:solidFill>
+          <a:schemeClr val="tx1">
+            <a:lumMod val="65000"/>
+            <a:lumOff val="35000"/>
+          </a:schemeClr>
+        </a:solidFill>
+        <a:round/>
+      </a:ln>
+    </cs:spPr>
+  </cs:errorBar>
+  <cs:floor>
+    <cs:lnRef idx="0"/>
+    <cs:fillRef idx="0"/>
+    <cs:effectRef idx="0"/>
+    <cs:fontRef idx="minor">
+      <a:schemeClr val="tx1"/>
+    </cs:fontRef>
+    <cs:spPr>
+      <a:noFill/>
+      <a:ln>
+        <a:noFill/>
+      </a:ln>
+    </cs:spPr>
+  </cs:floor>
+  <cs:gridlineMajor>
+    <cs:lnRef idx="0"/>
+    <cs:fillRef idx="0"/>
+    <cs:effectRef idx="0"/>
+    <cs:fontRef idx="minor">
+      <a:schemeClr val="tx1"/>
+    </cs:fontRef>
+    <cs:spPr>
+      <a:ln w="9525" cap="flat" cmpd="sng" algn="ctr">
+        <a:solidFill>
+          <a:schemeClr val="tx1">
+            <a:lumMod val="15000"/>
+            <a:lumOff val="85000"/>
+          </a:schemeClr>
+        </a:solidFill>
+        <a:round/>
+      </a:ln>
+    </cs:spPr>
+  </cs:gridlineMajor>
+  <cs:gridlineMinor>
+    <cs:lnRef idx="0"/>
+    <cs:fillRef idx="0"/>
+    <cs:effectRef idx="0"/>
+    <cs:fontRef idx="minor">
+      <a:schemeClr val="tx1"/>
+    </cs:fontRef>
+    <cs:spPr>
+      <a:ln w="9525" cap="flat" cmpd="sng" algn="ctr">
+        <a:solidFill>
+          <a:schemeClr val="tx1">
+            <a:lumMod val="5000"/>
+            <a:lumOff val="95000"/>
+          </a:schemeClr>
+        </a:solidFill>
+        <a:round/>
+      </a:ln>
+    </cs:spPr>
+  </cs:gridlineMinor>
+  <cs:hiLoLine>
+    <cs:lnRef idx="0"/>
+    <cs:fillRef idx="0"/>
+    <cs:effectRef idx="0"/>
+    <cs:fontRef idx="minor">
+      <a:schemeClr val="tx1"/>
+    </cs:fontRef>
+    <cs:spPr>
+      <a:ln w="9525" cap="flat" cmpd="sng" algn="ctr">
+        <a:solidFill>
+          <a:schemeClr val="tx1">
+            <a:lumMod val="75000"/>
+            <a:lumOff val="25000"/>
+          </a:schemeClr>
+        </a:solidFill>
+        <a:round/>
+      </a:ln>
+    </cs:spPr>
+  </cs:hiLoLine>
+  <cs:leaderLine>
+    <cs:lnRef idx="0"/>
+    <cs:fillRef idx="0"/>
+    <cs:effectRef idx="0"/>
+    <cs:fontRef idx="minor">
+      <a:schemeClr val="tx1"/>
+    </cs:fontRef>
+    <cs:spPr>
+      <a:ln w="9525" cap="flat" cmpd="sng" algn="ctr">
+        <a:solidFill>
+          <a:schemeClr val="tx1">
+            <a:lumMod val="35000"/>
+            <a:lumOff val="65000"/>
+          </a:schemeClr>
+        </a:solidFill>
+        <a:round/>
+      </a:ln>
+    </cs:spPr>
+  </cs:leaderLine>
+  <cs:legend>
+    <cs:lnRef idx="0"/>
+    <cs:fillRef idx="0"/>
+    <cs:effectRef idx="0"/>
+    <cs:fontRef idx="minor">
+      <a:schemeClr val="tx1">
+        <a:lumMod val="65000"/>
+        <a:lumOff val="35000"/>
+      </a:schemeClr>
+    </cs:fontRef>
+    <cs:defRPr sz="1197" kern="1200"/>
+  </cs:legend>
+  <cs:plotArea mods="allowNoFillOverride allowNoLineOverride">
+    <cs:lnRef idx="0"/>
+    <cs:fillRef idx="0"/>
+    <cs:effectRef idx="0"/>
+    <cs:fontRef idx="minor">
+      <a:schemeClr val="tx1"/>
+    </cs:fontRef>
+  </cs:plotArea>
+  <cs:plotArea3D mods="allowNoFillOverride allowNoLineOverride">
+    <cs:lnRef idx="0"/>
+    <cs:fillRef idx="0"/>
+    <cs:effectRef idx="0"/>
+    <cs:fontRef idx="minor">
+      <a:schemeClr val="tx1"/>
+    </cs:fontRef>
+  </cs:plotArea3D>
+  <cs:seriesAxis>
+    <cs:lnRef idx="0"/>
+    <cs:fillRef idx="0"/>
+    <cs:effectRef idx="0"/>
+    <cs:fontRef idx="minor">
+      <a:schemeClr val="tx1">
+        <a:lumMod val="65000"/>
+        <a:lumOff val="35000"/>
+      </a:schemeClr>
+    </cs:fontRef>
+    <cs:defRPr sz="1197" kern="1200"/>
+  </cs:seriesAxis>
+  <cs:seriesLine>
+    <cs:lnRef idx="0"/>
+    <cs:fillRef idx="0"/>
+    <cs:effectRef idx="0"/>
+    <cs:fontRef idx="minor">
+      <a:schemeClr val="tx1"/>
+    </cs:fontRef>
+    <cs:spPr>
+      <a:ln w="9525" cap="flat" cmpd="sng" algn="ctr">
+        <a:solidFill>
+          <a:schemeClr val="tx1">
+            <a:lumMod val="35000"/>
+            <a:lumOff val="65000"/>
+          </a:schemeClr>
+        </a:solidFill>
+        <a:round/>
+      </a:ln>
+    </cs:spPr>
+  </cs:seriesLine>
+  <cs:title>
+    <cs:lnRef idx="0"/>
+    <cs:fillRef idx="0"/>
+    <cs:effectRef idx="0"/>
+    <cs:fontRef idx="minor">
+      <a:schemeClr val="tx1">
+        <a:lumMod val="65000"/>
+        <a:lumOff val="35000"/>
+      </a:schemeClr>
+    </cs:fontRef>
+    <cs:defRPr sz="1862" b="0" kern="1200" spc="0" baseline="0"/>
+  </cs:title>
+  <cs:trendline>
+    <cs:lnRef idx="0">
+      <cs:styleClr val="auto"/>
+    </cs:lnRef>
+    <cs:fillRef idx="0"/>
+    <cs:effectRef idx="0"/>
+    <cs:fontRef idx="minor">
+      <a:schemeClr val="tx1"/>
+    </cs:fontRef>
+    <cs:spPr>
+      <a:ln w="19050" cap="rnd">
+        <a:solidFill>
+          <a:schemeClr val="phClr"/>
+        </a:solidFill>
+        <a:prstDash val="sysDot"/>
+      </a:ln>
+    </cs:spPr>
+  </cs:trendline>
+  <cs:trendlineLabel>
+    <cs:lnRef idx="0"/>
+    <cs:fillRef idx="0"/>
+    <cs:effectRef idx="0"/>
+    <cs:fontRef idx="minor">
+      <a:schemeClr val="tx1">
+        <a:lumMod val="65000"/>
+        <a:lumOff val="35000"/>
+      </a:schemeClr>
+    </cs:fontRef>
+    <cs:defRPr sz="1197" kern="1200"/>
+  </cs:trendlineLabel>
+  <cs:upBar>
+    <cs:lnRef idx="0"/>
+    <cs:fillRef idx="0"/>
+    <cs:effectRef idx="0"/>
+    <cs:fontRef idx="minor">
+      <a:schemeClr val="dk1"/>
+    </cs:fontRef>
+    <cs:spPr>
+      <a:solidFill>
+        <a:schemeClr val="lt1"/>
+      </a:solidFill>
+      <a:ln w="9525">
+        <a:solidFill>
+          <a:schemeClr val="tx1">
+            <a:lumMod val="15000"/>
+            <a:lumOff val="85000"/>
+          </a:schemeClr>
+        </a:solidFill>
+      </a:ln>
+    </cs:spPr>
+  </cs:upBar>
+  <cs:valueAxis>
+    <cs:lnRef idx="0"/>
+    <cs:fillRef idx="0"/>
+    <cs:effectRef idx="0"/>
+    <cs:fontRef idx="minor">
+      <a:schemeClr val="tx1">
+        <a:lumMod val="65000"/>
+        <a:lumOff val="35000"/>
+      </a:schemeClr>
+    </cs:fontRef>
+    <cs:defRPr sz="1197" kern="1200"/>
+  </cs:valueAxis>
+  <cs:wall>
+    <cs:lnRef idx="0"/>
+    <cs:fillRef idx="0"/>
+    <cs:effectRef idx="0"/>
+    <cs:fontRef idx="minor">
+      <a:schemeClr val="tx1"/>
+    </cs:fontRef>
+    <cs:spPr>
+      <a:noFill/>
+      <a:ln>
+        <a:noFill/>
+      </a:ln>
+    </cs:spPr>
+  </cs:wall>
+</cs:chartStyle>
+</file>
+
+<file path=ppt/charts/style3.xml><?xml version="1.0" encoding="utf-8"?>
+<cs:chartStyle xmlns:cs="http://schemas.microsoft.com/office/drawing/2012/chartStyle" xmlns:a="http://schemas.openxmlformats.org/drawingml/2006/main" id="216">
+  <cs:axisTitle>
+    <cs:lnRef idx="0"/>
+    <cs:fillRef idx="0"/>
+    <cs:effectRef idx="0"/>
+    <cs:fontRef idx="minor">
+      <a:schemeClr val="tx1">
+        <a:lumMod val="65000"/>
+        <a:lumOff val="35000"/>
+      </a:schemeClr>
+    </cs:fontRef>
+    <cs:defRPr sz="1330" kern="1200"/>
+  </cs:axisTitle>
+  <cs:categoryAxis>
+    <cs:lnRef idx="0"/>
+    <cs:fillRef idx="0"/>
+    <cs:effectRef idx="0"/>
+    <cs:fontRef idx="minor">
+      <a:schemeClr val="tx1">
+        <a:lumMod val="65000"/>
+        <a:lumOff val="35000"/>
+      </a:schemeClr>
+    </cs:fontRef>
+    <cs:spPr>
+      <a:ln w="9525" cap="flat" cmpd="sng" algn="ctr">
+        <a:solidFill>
+          <a:schemeClr val="tx1">
+            <a:lumMod val="15000"/>
+            <a:lumOff val="85000"/>
+          </a:schemeClr>
+        </a:solidFill>
+        <a:round/>
+      </a:ln>
+    </cs:spPr>
+    <cs:defRPr sz="1197" kern="1200"/>
+  </cs:categoryAxis>
+  <cs:chartArea mods="allowNoFillOverride allowNoLineOverride">
+    <cs:lnRef idx="0"/>
+    <cs:fillRef idx="0"/>
+    <cs:effectRef idx="0"/>
+    <cs:fontRef idx="minor">
+      <a:schemeClr val="tx1"/>
+    </cs:fontRef>
+    <cs:spPr>
+      <a:solidFill>
+        <a:schemeClr val="bg1"/>
+      </a:solidFill>
+      <a:ln w="9525" cap="flat" cmpd="sng" algn="ctr">
+        <a:solidFill>
+          <a:schemeClr val="tx1">
+            <a:lumMod val="15000"/>
+            <a:lumOff val="85000"/>
+          </a:schemeClr>
+        </a:solidFill>
+        <a:round/>
+      </a:ln>
+    </cs:spPr>
+    <cs:defRPr sz="1330" kern="1200"/>
+  </cs:chartArea>
+  <cs:dataLabel>
+    <cs:lnRef idx="0"/>
+    <cs:fillRef idx="0"/>
+    <cs:effectRef idx="0"/>
+    <cs:fontRef idx="minor">
+      <a:schemeClr val="tx1">
+        <a:lumMod val="75000"/>
+        <a:lumOff val="25000"/>
+      </a:schemeClr>
+    </cs:fontRef>
+    <cs:defRPr sz="1197" kern="1200"/>
+  </cs:dataLabel>
+  <cs:dataLabelCallout>
+    <cs:lnRef idx="0"/>
+    <cs:fillRef idx="0"/>
+    <cs:effectRef idx="0"/>
+    <cs:fontRef idx="minor">
+      <a:schemeClr val="dk1">
+        <a:lumMod val="65000"/>
+        <a:lumOff val="35000"/>
+      </a:schemeClr>
+    </cs:fontRef>
+    <cs:spPr>
+      <a:solidFill>
+        <a:schemeClr val="lt1"/>
+      </a:solidFill>
+      <a:ln>
+        <a:solidFill>
+          <a:schemeClr val="dk1">
+            <a:lumMod val="25000"/>
+            <a:lumOff val="75000"/>
+          </a:schemeClr>
+        </a:solidFill>
+      </a:ln>
+    </cs:spPr>
+    <cs:defRPr sz="1197" kern="1200"/>
+    <cs:bodyPr rot="0" spcFirstLastPara="1" vertOverflow="clip" horzOverflow="clip" vert="horz" wrap="square" lIns="36576" tIns="18288" rIns="36576" bIns="18288" anchor="ctr" anchorCtr="1">
+      <a:spAutoFit/>
+    </cs:bodyPr>
+  </cs:dataLabelCallout>
+  <cs:dataPoint>
+    <cs:lnRef idx="0"/>
+    <cs:fillRef idx="1">
+      <cs:styleClr val="auto"/>
+    </cs:fillRef>
+    <cs:effectRef idx="0"/>
+    <cs:fontRef idx="minor">
+      <a:schemeClr val="tx1"/>
+    </cs:fontRef>
+  </cs:dataPoint>
+  <cs:dataPoint3D>
+    <cs:lnRef idx="0"/>
+    <cs:fillRef idx="1">
+      <cs:styleClr val="auto"/>
+    </cs:fillRef>
+    <cs:effectRef idx="0"/>
+    <cs:fontRef idx="minor">
+      <a:schemeClr val="tx1"/>
+    </cs:fontRef>
+  </cs:dataPoint3D>
+  <cs:dataPointLine>
+    <cs:lnRef idx="0">
+      <cs:styleClr val="auto"/>
+    </cs:lnRef>
+    <cs:fillRef idx="1"/>
+    <cs:effectRef idx="0"/>
+    <cs:fontRef idx="minor">
+      <a:schemeClr val="tx1"/>
+    </cs:fontRef>
+    <cs:spPr>
+      <a:ln w="28575" cap="rnd">
+        <a:solidFill>
+          <a:schemeClr val="phClr"/>
+        </a:solidFill>
+        <a:round/>
+      </a:ln>
+    </cs:spPr>
+  </cs:dataPointLine>
+  <cs:dataPointMarker>
+    <cs:lnRef idx="0">
+      <cs:styleClr val="auto"/>
+    </cs:lnRef>
+    <cs:fillRef idx="1">
+      <cs:styleClr val="auto"/>
+    </cs:fillRef>
+    <cs:effectRef idx="0"/>
+    <cs:fontRef idx="minor">
+      <a:schemeClr val="tx1"/>
+    </cs:fontRef>
+    <cs:spPr>
+      <a:ln w="9525">
+        <a:solidFill>
+          <a:schemeClr val="phClr"/>
+        </a:solidFill>
+      </a:ln>
+    </cs:spPr>
+  </cs:dataPointMarker>
+  <cs:dataPointMarkerLayout symbol="circle" size="5"/>
+  <cs:dataPointWireframe>
+    <cs:lnRef idx="0">
+      <cs:styleClr val="auto"/>
+    </cs:lnRef>
+    <cs:fillRef idx="1"/>
+    <cs:effectRef idx="0"/>
+    <cs:fontRef idx="minor">
+      <a:schemeClr val="tx1"/>
+    </cs:fontRef>
+    <cs:spPr>
+      <a:ln w="9525" cap="rnd">
+        <a:solidFill>
+          <a:schemeClr val="phClr"/>
+        </a:solidFill>
+        <a:round/>
+      </a:ln>
+    </cs:spPr>
+  </cs:dataPointWireframe>
+  <cs:dataTable>
+    <cs:lnRef idx="0"/>
+    <cs:fillRef idx="0"/>
+    <cs:effectRef idx="0"/>
+    <cs:fontRef idx="minor">
+      <a:schemeClr val="tx1">
+        <a:lumMod val="65000"/>
+        <a:lumOff val="35000"/>
+      </a:schemeClr>
+    </cs:fontRef>
+    <cs:spPr>
+      <a:noFill/>
+      <a:ln w="9525" cap="flat" cmpd="sng" algn="ctr">
+        <a:solidFill>
+          <a:schemeClr val="tx1">
+            <a:lumMod val="15000"/>
+            <a:lumOff val="85000"/>
+          </a:schemeClr>
+        </a:solidFill>
+        <a:round/>
+      </a:ln>
+    </cs:spPr>
+    <cs:defRPr sz="1197" kern="1200"/>
+  </cs:dataTable>
+  <cs:downBar>
+    <cs:lnRef idx="0"/>
+    <cs:fillRef idx="0"/>
+    <cs:effectRef idx="0"/>
+    <cs:fontRef idx="minor">
+      <a:schemeClr val="tx1"/>
+    </cs:fontRef>
+    <cs:spPr>
+      <a:solidFill>
+        <a:schemeClr val="dk1">
+          <a:lumMod val="75000"/>
+          <a:lumOff val="25000"/>
+        </a:schemeClr>
+      </a:solidFill>
+      <a:ln w="9525" cap="flat" cmpd="sng" algn="ctr">
+        <a:solidFill>
+          <a:schemeClr val="tx1">
+            <a:lumMod val="65000"/>
+            <a:lumOff val="35000"/>
+          </a:schemeClr>
+        </a:solidFill>
+        <a:round/>
+      </a:ln>
+    </cs:spPr>
+  </cs:downBar>
+  <cs:dropLine>
+    <cs:lnRef idx="0"/>
+    <cs:fillRef idx="0"/>
+    <cs:effectRef idx="0"/>
+    <cs:fontRef idx="minor">
+      <a:schemeClr val="tx1"/>
+    </cs:fontRef>
+    <cs:spPr>
+      <a:ln w="9525" cap="flat" cmpd="sng" algn="ctr">
+        <a:solidFill>
+          <a:schemeClr val="tx1">
+            <a:lumMod val="35000"/>
+            <a:lumOff val="65000"/>
+          </a:schemeClr>
+        </a:solidFill>
+        <a:round/>
+      </a:ln>
+    </cs:spPr>
+  </cs:dropLine>
+  <cs:errorBar>
+    <cs:lnRef idx="0"/>
+    <cs:fillRef idx="0"/>
+    <cs:effectRef idx="0"/>
+    <cs:fontRef idx="minor">
+      <a:schemeClr val="tx1"/>
+    </cs:fontRef>
+    <cs:spPr>
+      <a:ln w="9525" cap="flat" cmpd="sng" algn="ctr">
+        <a:solidFill>
+          <a:schemeClr val="tx1">
+            <a:lumMod val="65000"/>
+            <a:lumOff val="35000"/>
+          </a:schemeClr>
+        </a:solidFill>
+        <a:round/>
+      </a:ln>
+    </cs:spPr>
+  </cs:errorBar>
+  <cs:floor>
+    <cs:lnRef idx="0"/>
+    <cs:fillRef idx="0"/>
+    <cs:effectRef idx="0"/>
+    <cs:fontRef idx="minor">
+      <a:schemeClr val="tx1"/>
+    </cs:fontRef>
+    <cs:spPr>
+      <a:noFill/>
+      <a:ln>
+        <a:noFill/>
+      </a:ln>
+    </cs:spPr>
+  </cs:floor>
+  <cs:gridlineMajor>
+    <cs:lnRef idx="0"/>
+    <cs:fillRef idx="0"/>
+    <cs:effectRef idx="0"/>
+    <cs:fontRef idx="minor">
+      <a:schemeClr val="tx1"/>
+    </cs:fontRef>
+    <cs:spPr>
+      <a:ln w="9525" cap="flat" cmpd="sng" algn="ctr">
+        <a:solidFill>
+          <a:schemeClr val="tx1">
+            <a:lumMod val="15000"/>
+            <a:lumOff val="85000"/>
+          </a:schemeClr>
+        </a:solidFill>
+        <a:round/>
+      </a:ln>
+    </cs:spPr>
+  </cs:gridlineMajor>
+  <cs:gridlineMinor>
+    <cs:lnRef idx="0"/>
+    <cs:fillRef idx="0"/>
+    <cs:effectRef idx="0"/>
+    <cs:fontRef idx="minor">
+      <a:schemeClr val="tx1"/>
+    </cs:fontRef>
+    <cs:spPr>
+      <a:ln w="9525" cap="flat" cmpd="sng" algn="ctr">
+        <a:solidFill>
+          <a:schemeClr val="tx1">
+            <a:lumMod val="5000"/>
+            <a:lumOff val="95000"/>
+          </a:schemeClr>
+        </a:solidFill>
+        <a:round/>
+      </a:ln>
+    </cs:spPr>
+  </cs:gridlineMinor>
+  <cs:hiLoLine>
+    <cs:lnRef idx="0"/>
+    <cs:fillRef idx="0"/>
+    <cs:effectRef idx="0"/>
+    <cs:fontRef idx="minor">
+      <a:schemeClr val="tx1"/>
+    </cs:fontRef>
+    <cs:spPr>
+      <a:ln w="9525" cap="flat" cmpd="sng" algn="ctr">
+        <a:solidFill>
+          <a:schemeClr val="tx1">
+            <a:lumMod val="50000"/>
+            <a:lumOff val="50000"/>
+          </a:schemeClr>
+        </a:solidFill>
+        <a:round/>
+      </a:ln>
+    </cs:spPr>
+  </cs:hiLoLine>
+  <cs:leaderLine>
+    <cs:lnRef idx="0"/>
+    <cs:fillRef idx="0"/>
+    <cs:effectRef idx="0"/>
+    <cs:fontRef idx="minor">
+      <a:schemeClr val="tx1"/>
+    </cs:fontRef>
+    <cs:spPr>
+      <a:ln w="9525" cap="flat" cmpd="sng" algn="ctr">
+        <a:solidFill>
+          <a:schemeClr val="tx1">
+            <a:lumMod val="35000"/>
+            <a:lumOff val="65000"/>
+          </a:schemeClr>
+        </a:solidFill>
+        <a:round/>
+      </a:ln>
+    </cs:spPr>
+  </cs:leaderLine>
+  <cs:legend>
+    <cs:lnRef idx="0"/>
+    <cs:fillRef idx="0"/>
+    <cs:effectRef idx="0"/>
+    <cs:fontRef idx="minor">
+      <a:schemeClr val="tx1">
+        <a:lumMod val="65000"/>
+        <a:lumOff val="35000"/>
+      </a:schemeClr>
+    </cs:fontRef>
+    <cs:defRPr sz="1197" kern="1200"/>
+  </cs:legend>
+  <cs:plotArea mods="allowNoFillOverride allowNoLineOverride">
+    <cs:lnRef idx="0"/>
+    <cs:fillRef idx="0"/>
+    <cs:effectRef idx="0"/>
+    <cs:fontRef idx="minor">
+      <a:schemeClr val="tx1"/>
+    </cs:fontRef>
+  </cs:plotArea>
+  <cs:plotArea3D mods="allowNoFillOverride allowNoLineOverride">
+    <cs:lnRef idx="0"/>
+    <cs:fillRef idx="0"/>
+    <cs:effectRef idx="0"/>
+    <cs:fontRef idx="minor">
+      <a:schemeClr val="tx1"/>
+    </cs:fontRef>
+  </cs:plotArea3D>
+  <cs:seriesAxis>
+    <cs:lnRef idx="0"/>
+    <cs:fillRef idx="0"/>
+    <cs:effectRef idx="0"/>
+    <cs:fontRef idx="minor">
+      <a:schemeClr val="tx1">
+        <a:lumMod val="65000"/>
+        <a:lumOff val="35000"/>
+      </a:schemeClr>
+    </cs:fontRef>
+    <cs:defRPr sz="1197" kern="1200"/>
+  </cs:seriesAxis>
+  <cs:seriesLine>
+    <cs:lnRef idx="0"/>
+    <cs:fillRef idx="0"/>
+    <cs:effectRef idx="0"/>
+    <cs:fontRef idx="minor">
+      <a:schemeClr val="tx1"/>
+    </cs:fontRef>
+    <cs:spPr>
+      <a:ln w="9525" cap="flat" cmpd="sng" algn="ctr">
+        <a:solidFill>
+          <a:schemeClr val="tx1">
+            <a:lumMod val="35000"/>
+            <a:lumOff val="65000"/>
+          </a:schemeClr>
+        </a:solidFill>
+        <a:round/>
+      </a:ln>
+    </cs:spPr>
+  </cs:seriesLine>
+  <cs:title>
+    <cs:lnRef idx="0"/>
+    <cs:fillRef idx="0"/>
+    <cs:effectRef idx="0"/>
+    <cs:fontRef idx="minor">
+      <a:schemeClr val="tx1">
+        <a:lumMod val="65000"/>
+        <a:lumOff val="35000"/>
+      </a:schemeClr>
+    </cs:fontRef>
+    <cs:defRPr sz="1862" b="0" kern="1200" spc="0" baseline="0"/>
+  </cs:title>
+  <cs:trendline>
+    <cs:lnRef idx="0">
+      <cs:styleClr val="auto"/>
+    </cs:lnRef>
+    <cs:fillRef idx="0"/>
+    <cs:effectRef idx="0"/>
+    <cs:fontRef idx="minor">
+      <a:schemeClr val="tx1"/>
+    </cs:fontRef>
+    <cs:spPr>
+      <a:ln w="19050" cap="rnd">
+        <a:solidFill>
+          <a:schemeClr val="phClr"/>
+        </a:solidFill>
+        <a:prstDash val="sysDot"/>
+      </a:ln>
+    </cs:spPr>
+  </cs:trendline>
+  <cs:trendlineLabel>
+    <cs:lnRef idx="0"/>
+    <cs:fillRef idx="0"/>
+    <cs:effectRef idx="0"/>
+    <cs:fontRef idx="minor">
+      <a:schemeClr val="tx1">
+        <a:lumMod val="65000"/>
+        <a:lumOff val="35000"/>
+      </a:schemeClr>
+    </cs:fontRef>
+    <cs:defRPr sz="1197" kern="1200"/>
+  </cs:trendlineLabel>
+  <cs:upBar>
+    <cs:lnRef idx="0"/>
+    <cs:fillRef idx="0"/>
+    <cs:effectRef idx="0"/>
+    <cs:fontRef idx="minor">
+      <a:schemeClr val="tx1"/>
+    </cs:fontRef>
+    <cs:spPr>
+      <a:solidFill>
+        <a:schemeClr val="lt1"/>
+      </a:solidFill>
+      <a:ln w="9525" cap="flat" cmpd="sng" algn="ctr">
+        <a:solidFill>
+          <a:schemeClr val="tx1">
+            <a:lumMod val="65000"/>
+            <a:lumOff val="35000"/>
+          </a:schemeClr>
+        </a:solidFill>
+        <a:round/>
+      </a:ln>
+    </cs:spPr>
+  </cs:upBar>
+  <cs:valueAxis>
+    <cs:lnRef idx="0"/>
+    <cs:fillRef idx="0"/>
+    <cs:effectRef idx="0"/>
+    <cs:fontRef idx="minor">
+      <a:schemeClr val="tx1">
+        <a:lumMod val="65000"/>
+        <a:lumOff val="35000"/>
+      </a:schemeClr>
+    </cs:fontRef>
+    <cs:defRPr sz="1197" kern="1200"/>
+  </cs:valueAxis>
+  <cs:wall>
+    <cs:lnRef idx="0"/>
+    <cs:fillRef idx="0"/>
+    <cs:effectRef idx="0"/>
+    <cs:fontRef idx="minor">
+      <a:schemeClr val="tx1"/>
+    </cs:fontRef>
+    <cs:spPr>
+      <a:noFill/>
+      <a:ln>
+        <a:noFill/>
+      </a:ln>
+    </cs:spPr>
+  </cs:wall>
+</cs:chartStyle>
 </file>
 
 <file path=ppt/notesMasters/notesMaster1.xml><?xml version="1.0" encoding="utf-8"?>
@@ -245,7 +3161,7 @@
           </a:lstStyle>
           <a:p>
             <a:fld id="{1325F515-76CE-4EEE-BEB8-05B5BC0E0A05}" type="datetimeFigureOut">
-              <a:t>6/18/2026</a:t>
+              <a:t>6/22/2026</a:t>
             </a:fld>
             <a:endParaRPr lang="en-US"/>
           </a:p>
@@ -3422,7 +6338,7 @@
               <a:buNone/>
             </a:pPr>
             <a:r>
-              <a:rPr lang="en-US" sz="750" b="1" kern="0" spc="150" dirty="0">
+              <a:rPr lang="en-US" sz="1400" b="1" kern="0" spc="150" dirty="0">
                 <a:solidFill>
                   <a:srgbClr val="00B4D8"/>
                 </a:solidFill>
@@ -3432,7 +6348,7 @@
               </a:rPr>
               <a:t>EXECUTIVE COMMENTARY</a:t>
             </a:r>
-            <a:endParaRPr lang="en-US" sz="750" dirty="0"/>
+            <a:endParaRPr lang="en-US" sz="1400" dirty="0"/>
           </a:p>
         </p:txBody>
       </p:sp>
@@ -3461,7 +6377,7 @@
               <a:buNone/>
             </a:pPr>
             <a:r>
-              <a:rPr lang="en-US" sz="1050" dirty="0">
+              <a:rPr lang="en-US" sz="1200" dirty="0">
                 <a:solidFill>
                   <a:srgbClr val="94A3B8"/>
                 </a:solidFill>
@@ -3471,7 +6387,7 @@
               </a:rPr>
               <a:t>{executive_commentary}</a:t>
             </a:r>
-            <a:endParaRPr lang="en-US" sz="1050" dirty="0"/>
+            <a:endParaRPr lang="en-US" sz="1200" dirty="0"/>
           </a:p>
         </p:txBody>
       </p:sp>
@@ -3885,46 +6801,7 @@
           <a:bodyPr/>
           <a:lstStyle/>
           <a:p>
-            <a:endParaRPr lang="en-US"/>
-          </a:p>
-        </p:txBody>
-      </p:sp>
-      <p:sp>
-        <p:nvSpPr>
-          <p:cNvPr id="11" name="Text 8"/>
-          <p:cNvSpPr/>
-          <p:nvPr/>
-        </p:nvSpPr>
-        <p:spPr>
-          <a:xfrm>
-            <a:off x="502920" y="3890772"/>
-            <a:ext cx="7388352" cy="329184"/>
-          </a:xfrm>
-          <a:prstGeom prst="rect">
-            <a:avLst/>
-          </a:prstGeom>
-          <a:noFill/>
-          <a:ln/>
-        </p:spPr>
-        <p:txBody>
-          <a:bodyPr wrap="square" lIns="0" tIns="0" rIns="0" bIns="0" rtlCol="0" anchor="ctr"/>
-          <a:lstStyle/>
-          <a:p>
-            <a:pPr marL="0" indent="0" algn="ctr">
-              <a:buNone/>
-            </a:pPr>
-            <a:r>
-              <a:rPr lang="en-US" sz="900" i="1" dirty="0">
-                <a:solidFill>
-                  <a:srgbClr val="4B5E78"/>
-                </a:solidFill>
-                <a:latin typeface="Calibri" pitchFamily="34" charset="0"/>
-                <a:ea typeface="Calibri" pitchFamily="34" charset="-122"/>
-                <a:cs typeface="Calibri" pitchFamily="34" charset="-120"/>
-              </a:rPr>
-              <a:t>Revenue Trend (Bar / Line) — Insert programmatically</a:t>
-            </a:r>
-            <a:endParaRPr lang="en-US" sz="900" dirty="0"/>
+            <a:endParaRPr lang="en-US" dirty="0"/>
           </a:p>
         </p:txBody>
       </p:sp>
@@ -4283,6 +7160,34 @@
           </a:p>
         </p:txBody>
       </p:sp>
+      <p:graphicFrame>
+        <p:nvGraphicFramePr>
+          <p:cNvPr id="23" name="revenue_trend_chart">
+            <a:extLst>
+              <a:ext uri="{FF2B5EF4-FFF2-40B4-BE49-F238E27FC236}">
+                <a16:creationId xmlns:a16="http://schemas.microsoft.com/office/drawing/2014/main" id="{B536A059-14CF-1917-2DB2-34C757AD397D}"/>
+              </a:ext>
+            </a:extLst>
+          </p:cNvPr>
+          <p:cNvGraphicFramePr/>
+          <p:nvPr>
+            <p:extLst>
+              <p:ext uri="{D42A27DB-BD31-4B8C-83A1-F6EECF244321}">
+                <p14:modId xmlns:p14="http://schemas.microsoft.com/office/powerpoint/2010/main" val="1062117357"/>
+              </p:ext>
+            </p:extLst>
+          </p:nvPr>
+        </p:nvGraphicFramePr>
+        <p:xfrm>
+          <a:off x="685800" y="1673352"/>
+          <a:ext cx="7046495" cy="4464981"/>
+        </p:xfrm>
+        <a:graphic>
+          <a:graphicData uri="http://schemas.openxmlformats.org/drawingml/2006/chart">
+            <c:chart xmlns:c="http://schemas.openxmlformats.org/drawingml/2006/chart" xmlns:r="http://schemas.openxmlformats.org/officeDocument/2006/relationships" r:id="rId3"/>
+          </a:graphicData>
+        </a:graphic>
+      </p:graphicFrame>
     </p:spTree>
   </p:cSld>
   <p:clrMapOvr>
@@ -4783,45 +7688,6 @@
       </p:sp>
       <p:sp>
         <p:nvSpPr>
-          <p:cNvPr id="16" name="Text 13"/>
-          <p:cNvSpPr/>
-          <p:nvPr/>
-        </p:nvSpPr>
-        <p:spPr>
-          <a:xfrm>
-            <a:off x="502920" y="4059936"/>
-            <a:ext cx="7388352" cy="329184"/>
-          </a:xfrm>
-          <a:prstGeom prst="rect">
-            <a:avLst/>
-          </a:prstGeom>
-          <a:noFill/>
-          <a:ln/>
-        </p:spPr>
-        <p:txBody>
-          <a:bodyPr wrap="square" lIns="0" tIns="0" rIns="0" bIns="0" rtlCol="0" anchor="ctr"/>
-          <a:lstStyle/>
-          <a:p>
-            <a:pPr marL="0" indent="0" algn="ctr">
-              <a:buNone/>
-            </a:pPr>
-            <a:r>
-              <a:rPr lang="en-US" sz="900" i="1" dirty="0">
-                <a:solidFill>
-                  <a:srgbClr val="4B5E78"/>
-                </a:solidFill>
-                <a:latin typeface="Calibri" pitchFamily="34" charset="0"/>
-                <a:ea typeface="Calibri" pitchFamily="34" charset="-122"/>
-                <a:cs typeface="Calibri" pitchFamily="34" charset="-120"/>
-              </a:rPr>
-              <a:t>Cost Breakdown (Bar / Area) — Insert programmatically</a:t>
-            </a:r>
-            <a:endParaRPr lang="en-US" sz="900" dirty="0"/>
-          </a:p>
-        </p:txBody>
-      </p:sp>
-      <p:sp>
-        <p:nvSpPr>
           <p:cNvPr id="17" name="Shape 14"/>
           <p:cNvSpPr/>
           <p:nvPr/>
@@ -5175,6 +8041,34 @@
           </a:p>
         </p:txBody>
       </p:sp>
+      <p:graphicFrame>
+        <p:nvGraphicFramePr>
+          <p:cNvPr id="28" name="cost_breakdown_chart">
+            <a:extLst>
+              <a:ext uri="{FF2B5EF4-FFF2-40B4-BE49-F238E27FC236}">
+                <a16:creationId xmlns:a16="http://schemas.microsoft.com/office/drawing/2014/main" id="{627A7A03-D15B-5346-D135-CD12A52C320F}"/>
+              </a:ext>
+            </a:extLst>
+          </p:cNvPr>
+          <p:cNvGraphicFramePr/>
+          <p:nvPr>
+            <p:extLst>
+              <p:ext uri="{D42A27DB-BD31-4B8C-83A1-F6EECF244321}">
+                <p14:modId xmlns:p14="http://schemas.microsoft.com/office/powerpoint/2010/main" val="1167755080"/>
+              </p:ext>
+            </p:extLst>
+          </p:nvPr>
+        </p:nvGraphicFramePr>
+        <p:xfrm>
+          <a:off x="667512" y="1938528"/>
+          <a:ext cx="7046273" cy="4535424"/>
+        </p:xfrm>
+        <a:graphic>
+          <a:graphicData uri="http://schemas.openxmlformats.org/drawingml/2006/chart">
+            <c:chart xmlns:c="http://schemas.openxmlformats.org/drawingml/2006/chart" xmlns:r="http://schemas.openxmlformats.org/officeDocument/2006/relationships" r:id="rId3"/>
+          </a:graphicData>
+        </a:graphic>
+      </p:graphicFrame>
     </p:spTree>
   </p:cSld>
   <p:clrMapOvr>
@@ -6360,45 +9254,6 @@
       </p:sp>
       <p:sp>
         <p:nvSpPr>
-          <p:cNvPr id="8" name="Text 5"/>
-          <p:cNvSpPr/>
-          <p:nvPr/>
-        </p:nvSpPr>
-        <p:spPr>
-          <a:xfrm>
-            <a:off x="502920" y="3497580"/>
-            <a:ext cx="5303520" cy="329184"/>
-          </a:xfrm>
-          <a:prstGeom prst="rect">
-            <a:avLst/>
-          </a:prstGeom>
-          <a:noFill/>
-          <a:ln/>
-        </p:spPr>
-        <p:txBody>
-          <a:bodyPr wrap="square" lIns="0" tIns="0" rIns="0" bIns="0" rtlCol="0" anchor="ctr"/>
-          <a:lstStyle/>
-          <a:p>
-            <a:pPr marL="0" indent="0" algn="ctr">
-              <a:buNone/>
-            </a:pPr>
-            <a:r>
-              <a:rPr lang="en-US" sz="900" i="1" dirty="0">
-                <a:solidFill>
-                  <a:srgbClr val="4B5E78"/>
-                </a:solidFill>
-                <a:latin typeface="Calibri" pitchFamily="34" charset="0"/>
-                <a:ea typeface="Calibri" pitchFamily="34" charset="-122"/>
-                <a:cs typeface="Calibri" pitchFamily="34" charset="-120"/>
-              </a:rPr>
-              <a:t>Sector Revenue (Horizontal Bar) — Insert programmatically</a:t>
-            </a:r>
-            <a:endParaRPr lang="en-US" sz="900" dirty="0"/>
-          </a:p>
-        </p:txBody>
-      </p:sp>
-      <p:sp>
-        <p:nvSpPr>
           <p:cNvPr id="9" name="Shape 6"/>
           <p:cNvSpPr/>
           <p:nvPr/>
@@ -7408,6 +10263,34 @@
           </a:p>
         </p:txBody>
       </p:sp>
+      <p:graphicFrame>
+        <p:nvGraphicFramePr>
+          <p:cNvPr id="37" name="sector_revenue_chart">
+            <a:extLst>
+              <a:ext uri="{FF2B5EF4-FFF2-40B4-BE49-F238E27FC236}">
+                <a16:creationId xmlns:a16="http://schemas.microsoft.com/office/drawing/2014/main" id="{C408F873-D7B2-C8DB-B028-9F6F9921EBAE}"/>
+              </a:ext>
+            </a:extLst>
+          </p:cNvPr>
+          <p:cNvGraphicFramePr/>
+          <p:nvPr>
+            <p:extLst>
+              <p:ext uri="{D42A27DB-BD31-4B8C-83A1-F6EECF244321}">
+                <p14:modId xmlns:p14="http://schemas.microsoft.com/office/powerpoint/2010/main" val="3302382428"/>
+              </p:ext>
+            </p:extLst>
+          </p:nvPr>
+        </p:nvGraphicFramePr>
+        <p:xfrm>
+          <a:off x="502920" y="719666"/>
+          <a:ext cx="5303520" cy="5827438"/>
+        </p:xfrm>
+        <a:graphic>
+          <a:graphicData uri="http://schemas.openxmlformats.org/drawingml/2006/chart">
+            <c:chart xmlns:c="http://schemas.openxmlformats.org/drawingml/2006/chart" xmlns:r="http://schemas.openxmlformats.org/officeDocument/2006/relationships" r:id="rId3"/>
+          </a:graphicData>
+        </a:graphic>
+      </p:graphicFrame>
     </p:spTree>
   </p:cSld>
   <p:clrMapOvr>
@@ -7601,7 +10484,7 @@
               <a:buNone/>
             </a:pPr>
             <a:r>
-              <a:rPr lang="en-US" sz="800" b="1" kern="0" spc="200" dirty="0">
+              <a:rPr lang="en-US" sz="1400" b="1" kern="0" spc="200" dirty="0">
                 <a:solidFill>
                   <a:srgbClr val="00B4D8"/>
                 </a:solidFill>
@@ -7611,7 +10494,7 @@
               </a:rPr>
               <a:t>KEY DRIVERS</a:t>
             </a:r>
-            <a:endParaRPr lang="en-US" sz="800" dirty="0"/>
+            <a:endParaRPr lang="en-US" sz="1400" dirty="0"/>
           </a:p>
         </p:txBody>
       </p:sp>
@@ -7810,7 +10693,7 @@
               <a:buNone/>
             </a:pPr>
             <a:r>
-              <a:rPr lang="en-US" sz="800" b="1" kern="0" spc="200" dirty="0">
+              <a:rPr lang="en-US" sz="1400" b="1" kern="0" spc="200" dirty="0">
                 <a:solidFill>
                   <a:srgbClr val="00B4D8"/>
                 </a:solidFill>
@@ -7820,7 +10703,7 @@
               </a:rPr>
               <a:t>BOTTOM LINE</a:t>
             </a:r>
-            <a:endParaRPr lang="en-US" sz="800" dirty="0"/>
+            <a:endParaRPr lang="en-US" sz="1400" dirty="0"/>
           </a:p>
         </p:txBody>
       </p:sp>
@@ -7849,7 +10732,7 @@
               <a:buNone/>
             </a:pPr>
             <a:r>
-              <a:rPr lang="en-US" sz="1150" dirty="0">
+              <a:rPr lang="en-US" sz="1200" dirty="0">
                 <a:solidFill>
                   <a:srgbClr val="94A3B8"/>
                 </a:solidFill>
@@ -7859,7 +10742,7 @@
               </a:rPr>
               <a:t>{bottom_line_summary}</a:t>
             </a:r>
-            <a:endParaRPr lang="en-US" sz="1150" dirty="0"/>
+            <a:endParaRPr lang="en-US" sz="1200" dirty="0"/>
           </a:p>
         </p:txBody>
       </p:sp>

</xml_diff>